<commit_message>
chore: finalize GASOK evidence and deployment guardrails
</commit_message>
<xml_diff>
--- a/docs/pitch/GiwaPay-GASOK-Pitch-Deck.pptx
+++ b/docs/pitch/GiwaPay-GASOK-Pitch-Deck.pptx
@@ -2,20 +2,20 @@
 <file path=ppt/presentation.xml><?xml version="1.0" encoding="utf-8"?>
 <p:presentation xmlns:p="http://schemas.openxmlformats.org/presentationml/2006/main">
   <p:sldMasterIdLst>
-    <p:sldMasterId xmlns:r="http://schemas.openxmlformats.org/officeDocument/2006/relationships" id="2147483648" r:id="Rc4dac444b0cb42d5"/>
+    <p:sldMasterId xmlns:r="http://schemas.openxmlformats.org/officeDocument/2006/relationships" id="2147483648" r:id="R0627cedd24b94f65"/>
   </p:sldMasterIdLst>
   <p:notesMasterIdLst>
-    <p:notesMasterId xmlns:r="http://schemas.openxmlformats.org/officeDocument/2006/relationships" r:id="R3f8c9ebd4e8141ca"/>
+    <p:notesMasterId xmlns:r="http://schemas.openxmlformats.org/officeDocument/2006/relationships" r:id="Rbd3e3743af4b436e"/>
   </p:notesMasterIdLst>
   <p:sldIdLst>
-    <p:sldId xmlns:r="http://schemas.openxmlformats.org/officeDocument/2006/relationships" id="256" r:id="Rfe289e0895434cae"/>
-    <p:sldId xmlns:r="http://schemas.openxmlformats.org/officeDocument/2006/relationships" id="257" r:id="R1305ff10d1604f48"/>
-    <p:sldId xmlns:r="http://schemas.openxmlformats.org/officeDocument/2006/relationships" id="258" r:id="Ref0f862e40734ee5"/>
-    <p:sldId xmlns:r="http://schemas.openxmlformats.org/officeDocument/2006/relationships" id="259" r:id="R3221764f751b495c"/>
-    <p:sldId xmlns:r="http://schemas.openxmlformats.org/officeDocument/2006/relationships" id="260" r:id="R1915daec4d684aff"/>
-    <p:sldId xmlns:r="http://schemas.openxmlformats.org/officeDocument/2006/relationships" id="261" r:id="Rd2e2ed724c654063"/>
-    <p:sldId xmlns:r="http://schemas.openxmlformats.org/officeDocument/2006/relationships" id="262" r:id="R637df474eb1d4f57"/>
-    <p:sldId xmlns:r="http://schemas.openxmlformats.org/officeDocument/2006/relationships" id="263" r:id="R186fc8fd928a4168"/>
+    <p:sldId xmlns:r="http://schemas.openxmlformats.org/officeDocument/2006/relationships" id="256" r:id="Rceb551953c2942ed"/>
+    <p:sldId xmlns:r="http://schemas.openxmlformats.org/officeDocument/2006/relationships" id="257" r:id="Rf2018c63b522450c"/>
+    <p:sldId xmlns:r="http://schemas.openxmlformats.org/officeDocument/2006/relationships" id="258" r:id="R115a0d5d3c964881"/>
+    <p:sldId xmlns:r="http://schemas.openxmlformats.org/officeDocument/2006/relationships" id="259" r:id="Ree2fa021876b4cdc"/>
+    <p:sldId xmlns:r="http://schemas.openxmlformats.org/officeDocument/2006/relationships" id="260" r:id="R04d53b0dced74938"/>
+    <p:sldId xmlns:r="http://schemas.openxmlformats.org/officeDocument/2006/relationships" id="261" r:id="R9f1c7ae1372e4d90"/>
+    <p:sldId xmlns:r="http://schemas.openxmlformats.org/officeDocument/2006/relationships" id="262" r:id="R9a4e642cde194785"/>
+    <p:sldId xmlns:r="http://schemas.openxmlformats.org/officeDocument/2006/relationships" id="263" r:id="Rdfd7319447f24638"/>
   </p:sldIdLst>
   <p:sldSz cx="12192000" cy="6858000"/>
   <p:notesSz cx="6858000" cy="9144000"/>
@@ -754,27 +754,37 @@
           </a:p>
           <a:p xmlns:a="http://schemas.openxmlformats.org/drawingml/2006/main">
             <a:r>
-              <a:t>- https://docs.giwa.io/get-started/connect-to-giwa</a:t>
-            </a:r>
-          </a:p>
-          <a:p xmlns:a="http://schemas.openxmlformats.org/drawingml/2006/main">
-            <a:r>
-              <a:t>- https://docs.giwa.io/network-information/transaction-fees</a:t>
-            </a:r>
-          </a:p>
-          <a:p xmlns:a="http://schemas.openxmlformats.org/drawingml/2006/main">
-            <a:r>
-              <a:t>- https://docs.giwa.io/giwa-ecosystem/dojang</a:t>
-            </a:r>
-          </a:p>
-          <a:p xmlns:a="http://schemas.openxmlformats.org/drawingml/2006/main">
-            <a:r>
-              <a:t>- https://docs.giwa.io/giwa-ecosystem/up-id</a:t>
-            </a:r>
-          </a:p>
-          <a:p xmlns:a="http://schemas.openxmlformats.org/drawingml/2006/main">
-            <a:r>
-              <a:t>- https://github.com/eomyunsig-debug/giwapay/blob/main/docs/giwa-wallet-embedded-mode.md</a:t>
+              <a:t>- https://docs.giwa.io/giwa-chain/en</a:t>
+            </a:r>
+          </a:p>
+          <a:p xmlns:a="http://schemas.openxmlformats.org/drawingml/2006/main">
+            <a:r>
+              <a:t>- https://docs.giwa.io/giwa-chain/en/get-started/connect-to-giwa</a:t>
+            </a:r>
+          </a:p>
+          <a:p xmlns:a="http://schemas.openxmlformats.org/drawingml/2006/main">
+            <a:r>
+              <a:t>- https://docs.giwa.io/giwa-chain/en/network-information/transaction-fees</a:t>
+            </a:r>
+          </a:p>
+          <a:p xmlns:a="http://schemas.openxmlformats.org/drawingml/2006/main">
+            <a:r>
+              <a:t>- https://docs.giwa.io/giwa-chain/en/giwa-ecosystem/dojang</a:t>
+            </a:r>
+          </a:p>
+          <a:p xmlns:a="http://schemas.openxmlformats.org/drawingml/2006/main">
+            <a:r>
+              <a:t>- https://docs.giwa.io/giwa-chain/en/giwa-ecosystem/giwa-id</a:t>
+            </a:r>
+          </a:p>
+          <a:p xmlns:a="http://schemas.openxmlformats.org/drawingml/2006/main">
+            <a:r>
+              <a:t>- https://docs.giwa.io/giwa-chain/en/terms-and-policies/testnet-terms-of-use</a:t>
+            </a:r>
+          </a:p>
+          <a:p xmlns:a="http://schemas.openxmlformats.org/drawingml/2006/main">
+            <a:r>
+              <a:t>- https://github.com/eomyunsig-debug/giwapay/blob/agent/giwa-program-submission/docs/giwa-wallet-embedded-mode.md</a:t>
             </a:r>
           </a:p>
           <a:p xmlns:a="http://schemas.openxmlformats.org/drawingml/2006/main">
@@ -879,6 +889,11 @@
           </a:p>
           <a:p xmlns:a="http://schemas.openxmlformats.org/drawingml/2006/main">
             <a:r>
+              <a:t>- https://github.com/eomyunsig-debug/giwapay/actions/runs/30518612814</a:t>
+            </a:r>
+          </a:p>
+          <a:p xmlns:a="http://schemas.openxmlformats.org/drawingml/2006/main">
+            <a:r>
               <a:t>- https://sepolia-explorer.giwa.io</a:t>
             </a:r>
           </a:p>
@@ -954,7 +969,7 @@
           <a:lstStyle xmlns:a="http://schemas.openxmlformats.org/drawingml/2006/main"/>
           <a:p xmlns:a="http://schemas.openxmlformats.org/drawingml/2006/main">
             <a:r>
-              <a:t>1.9621조원은 거시 참고 기준이며 GiwaPay TAM으로 사용하지 않습니다. 평가자가 보는 세 숫자는 현재 traction이 아니라 Phase 3에서 관찰할 목표입니다.</a:t>
+              <a:t>1.9621조원은 거시 참고 기준이며 GiwaPay TAM으로 사용하지 않습니다. Low/Base/High는 각각 98,105,000원, 981,050,000원, 3,924,200,000원의 가정 기반 연간 처리액입니다. 0.5% 예시 수수료는 490,525원, 4,905,250원, 19,621,000원입니다. 저장소와 공개 자료에서 검증된 인터뷰·서면 관심·merchant 통합은 모두 0이며, 비공개·오프라인 활동은 신청자가 확인해야 합니다.</a:t>
             </a:r>
           </a:p>
           <a:p xmlns:a="http://schemas.openxmlformats.org/drawingml/2006/main">
@@ -974,7 +989,7 @@
           </a:p>
           <a:p xmlns:a="http://schemas.openxmlformats.org/drawingml/2006/main">
             <a:r>
-              <a:t>- https://github.com/eomyunsig-debug/giwapay/blob/main/docs/market-opportunity.md</a:t>
+              <a:t>- https://github.com/eomyunsig-debug/giwapay/blob/agent/giwa-program-submission/docs/market-opportunity.md</a:t>
             </a:r>
           </a:p>
           <a:p xmlns:a="http://schemas.openxmlformats.org/drawingml/2006/main">
@@ -1064,12 +1079,12 @@
           </a:p>
           <a:p xmlns:a="http://schemas.openxmlformats.org/drawingml/2006/main">
             <a:r>
-              <a:t>- https://github.com/eomyunsig-debug/giwapay/blob/main/docs/market-opportunity.md</a:t>
-            </a:r>
-          </a:p>
-          <a:p xmlns:a="http://schemas.openxmlformats.org/drawingml/2006/main">
-            <a:r>
-              <a:t>- https://github.com/eomyunsig-debug/giwapay/blob/main/docs/giwa-wallet-embedded-mode.md</a:t>
+              <a:t>- https://github.com/eomyunsig-debug/giwapay/blob/agent/giwa-program-submission/docs/market-opportunity.md</a:t>
+            </a:r>
+          </a:p>
+          <a:p xmlns:a="http://schemas.openxmlformats.org/drawingml/2006/main">
+            <a:r>
+              <a:t>- https://github.com/eomyunsig-debug/giwapay/blob/agent/giwa-program-submission/docs/giwa-wallet-embedded-mode.md</a:t>
             </a:r>
           </a:p>
           <a:p xmlns:a="http://schemas.openxmlformats.org/drawingml/2006/main">
@@ -1247,7 +1262,7 @@
   </p:cSld>
   <p:clrMap bg1="lt1" tx1="dk1" bg2="lt2" tx2="dk2" accent1="accent1" accent2="accent2" accent3="accent3" accent4="accent4" accent5="accent5" accent6="accent6" hlink="hlink" folHlink="folHlink"/>
   <p:sldLayoutIdLst>
-    <p:sldLayoutId xmlns:r="http://schemas.openxmlformats.org/officeDocument/2006/relationships" id="2147483649" r:id="R478e3485ec6d415c"/>
+    <p:sldLayoutId xmlns:r="http://schemas.openxmlformats.org/officeDocument/2006/relationships" id="2147483649" r:id="R3b101e935577408a"/>
   </p:sldLayoutIdLst>
   <p:txStyles>
     <p:titleStyle>
@@ -1798,7 +1813,7 @@
           <p:cNvPr id="10" name="cover-eyebrow">
             <a:extLst xmlns:a="http://schemas.openxmlformats.org/drawingml/2006/main">
               <a:ext uri="{FF2B5EF4-FFF2-40B4-BE49-F238E27FC236}">
-                <a16:creationId xmlns:a16="http://schemas.microsoft.com/office/drawing/2014/main" id="{FC4D9ABB-ADCF-48E0-8ACC-66A4EA35F8A1}"/>
+                <a16:creationId xmlns:a16="http://schemas.microsoft.com/office/drawing/2014/main" id="{9ECEAC08-E383-43C0-88E3-B4944E563574}"/>
               </a:ext>
             </a:extLst>
           </p:cNvPr>
@@ -1860,7 +1875,7 @@
           <p:cNvPr id="2" name="cover-wordmark">
             <a:extLst xmlns:a="http://schemas.openxmlformats.org/drawingml/2006/main">
               <a:ext uri="{FF2B5EF4-FFF2-40B4-BE49-F238E27FC236}">
-                <a16:creationId xmlns:a16="http://schemas.microsoft.com/office/drawing/2014/main" id="{E0109867-6EB2-40EB-840B-DA26A8CFFD75}"/>
+                <a16:creationId xmlns:a16="http://schemas.microsoft.com/office/drawing/2014/main" id="{4D6C913F-22EA-4FE1-8235-1E44DA58D086}"/>
               </a:ext>
             </a:extLst>
           </p:cNvPr>
@@ -1922,7 +1937,7 @@
           <p:cNvPr id="3" name="cover-title">
             <a:extLst xmlns:a="http://schemas.openxmlformats.org/drawingml/2006/main">
               <a:ext uri="{FF2B5EF4-FFF2-40B4-BE49-F238E27FC236}">
-                <a16:creationId xmlns:a16="http://schemas.microsoft.com/office/drawing/2014/main" id="{C7C3909B-2C2B-4E9F-A80F-236ED312DE5C}"/>
+                <a16:creationId xmlns:a16="http://schemas.microsoft.com/office/drawing/2014/main" id="{E489364A-33F2-4ABB-8227-D4B76534F30A}"/>
               </a:ext>
             </a:extLst>
           </p:cNvPr>
@@ -1974,7 +1989,7 @@
                 <a:ea typeface="Apple SD Gothic Neo"/>
                 <a:cs typeface="Apple SD Gothic Neo"/>
               </a:rPr>
-              <a:t>고객은 가진 자산으로,</a:t>
+              <a:t>고객은 지원 자산으로,</a:t>
             </a:r>
           </a:p>
           <a:p xmlns:a="http://schemas.openxmlformats.org/drawingml/2006/main">
@@ -2011,7 +2026,7 @@
           <p:cNvPr id="4" name="cover-subtitle">
             <a:extLst xmlns:a="http://schemas.openxmlformats.org/drawingml/2006/main">
               <a:ext uri="{FF2B5EF4-FFF2-40B4-BE49-F238E27FC236}">
-                <a16:creationId xmlns:a16="http://schemas.microsoft.com/office/drawing/2014/main" id="{2D65C4B1-FE5A-43B7-83E6-BDFECDD4C5E4}"/>
+                <a16:creationId xmlns:a16="http://schemas.microsoft.com/office/drawing/2014/main" id="{0ED82B18-937E-437A-B451-0E2B22D6D64E}"/>
               </a:ext>
             </a:extLst>
           </p:cNvPr>
@@ -2073,7 +2088,7 @@
           <p:cNvPr id="5" name="cover-status-bg">
             <a:extLst xmlns:a="http://schemas.openxmlformats.org/drawingml/2006/main">
               <a:ext uri="{FF2B5EF4-FFF2-40B4-BE49-F238E27FC236}">
-                <a16:creationId xmlns:a16="http://schemas.microsoft.com/office/drawing/2014/main" id="{8EDE8D3F-0B4D-42EA-8076-9B25952DF627}"/>
+                <a16:creationId xmlns:a16="http://schemas.microsoft.com/office/drawing/2014/main" id="{8DD840B1-7667-487A-A5FC-481A42384739}"/>
               </a:ext>
             </a:extLst>
           </p:cNvPr>
@@ -2104,7 +2119,7 @@
           <p:cNvPr id="6" name="cover-status">
             <a:extLst xmlns:a="http://schemas.openxmlformats.org/drawingml/2006/main">
               <a:ext uri="{FF2B5EF4-FFF2-40B4-BE49-F238E27FC236}">
-                <a16:creationId xmlns:a16="http://schemas.microsoft.com/office/drawing/2014/main" id="{376980C2-F9A2-4E3F-A833-B15376927C7A}"/>
+                <a16:creationId xmlns:a16="http://schemas.microsoft.com/office/drawing/2014/main" id="{8D4CE8C0-427A-4322-8559-9542A59DD22C}"/>
               </a:ext>
             </a:extLst>
           </p:cNvPr>
@@ -2166,7 +2181,7 @@
           <p:cNvPr id="7" name="cover-boundary">
             <a:extLst xmlns:a="http://schemas.openxmlformats.org/drawingml/2006/main">
               <a:ext uri="{FF2B5EF4-FFF2-40B4-BE49-F238E27FC236}">
-                <a16:creationId xmlns:a16="http://schemas.microsoft.com/office/drawing/2014/main" id="{AA5F67BA-3A43-4DC5-9707-5807A6A4C12E}"/>
+                <a16:creationId xmlns:a16="http://schemas.microsoft.com/office/drawing/2014/main" id="{9EE55477-9160-4516-8237-6A2799E7ED83}"/>
               </a:ext>
             </a:extLst>
           </p:cNvPr>
@@ -2200,17 +2215,17 @@
                 <a:spcPct val="100000"/>
               </a:lnSpc>
               <a:buNone/>
-              <a:defRPr sz="1050" b="0">
-                <a:solidFill>
-                  <a:srgbClr val="5F6661"/>
-                </a:solidFill>
-                <a:latin typeface="Apple SD Gothic Neo"/>
-                <a:ea typeface="Apple SD Gothic Neo"/>
-                <a:cs typeface="Apple SD Gothic Neo"/>
-              </a:defRPr>
-            </a:pPr>
-            <a:r>
-              <a:rPr sz="1050" b="0">
+              <a:defRPr sz="1200" b="0">
+                <a:solidFill>
+                  <a:srgbClr val="5F6661"/>
+                </a:solidFill>
+                <a:latin typeface="Apple SD Gothic Neo"/>
+                <a:ea typeface="Apple SD Gothic Neo"/>
+                <a:cs typeface="Apple SD Gothic Neo"/>
+              </a:defRPr>
+            </a:pPr>
+            <a:r>
+              <a:rPr sz="1200" b="0">
                 <a:solidFill>
                   <a:srgbClr val="5F6661"/>
                 </a:solidFill>
@@ -2228,7 +2243,7 @@
           <p:cNvPr id="8" name="cover-image-bg">
             <a:extLst xmlns:a="http://schemas.openxmlformats.org/drawingml/2006/main">
               <a:ext uri="{FF2B5EF4-FFF2-40B4-BE49-F238E27FC236}">
-                <a16:creationId xmlns:a16="http://schemas.microsoft.com/office/drawing/2014/main" id="{3B59B1FF-27C2-4B27-99EA-06177D8F95FE}"/>
+                <a16:creationId xmlns:a16="http://schemas.microsoft.com/office/drawing/2014/main" id="{C09C6223-9FC3-43ED-987F-02BA441EECB0}"/>
               </a:ext>
             </a:extLst>
           </p:cNvPr>
@@ -2265,7 +2280,7 @@
           <p:nvPr/>
         </p:nvPicPr>
         <p:blipFill>
-          <a:blip xmlns:r="http://schemas.openxmlformats.org/officeDocument/2006/relationships" xmlns:a="http://schemas.openxmlformats.org/drawingml/2006/main" r:embed="R6c95fd26c2634391"/>
+          <a:blip xmlns:r="http://schemas.openxmlformats.org/officeDocument/2006/relationships" xmlns:a="http://schemas.openxmlformats.org/drawingml/2006/main" r:embed="Rc31707f1193a48db"/>
           <a:stretch xmlns:a="http://schemas.openxmlformats.org/drawingml/2006/main"/>
         </p:blipFill>
         <p:spPr>
@@ -2281,7 +2296,7 @@
     </p:spTree>
     <p:extLst>
       <p:ext uri="{BB962C8B-B14F-4D97-AF65-F5344CB8AC3E}">
-        <p14:creationId xmlns:p14="http://schemas.microsoft.com/office/powerpoint/2010/main" val="398812166"/>
+        <p14:creationId xmlns:p14="http://schemas.microsoft.com/office/powerpoint/2010/main" val="587989356"/>
       </p:ext>
     </p:extLst>
   </p:cSld>
@@ -2312,7 +2327,7 @@
           <p:cNvPr id="21" name="slide-2-title">
             <a:extLst xmlns:a="http://schemas.openxmlformats.org/drawingml/2006/main">
               <a:ext uri="{FF2B5EF4-FFF2-40B4-BE49-F238E27FC236}">
-                <a16:creationId xmlns:a16="http://schemas.microsoft.com/office/drawing/2014/main" id="{E3595C31-7045-43EE-AAAE-A42A26DB9DB2}"/>
+                <a16:creationId xmlns:a16="http://schemas.microsoft.com/office/drawing/2014/main" id="{17E46973-2E89-40CC-87D5-96FF5B36C10B}"/>
               </a:ext>
             </a:extLst>
           </p:cNvPr>
@@ -2374,7 +2389,7 @@
           <p:cNvPr id="2" name="slide-2-subtitle">
             <a:extLst xmlns:a="http://schemas.openxmlformats.org/drawingml/2006/main">
               <a:ext uri="{FF2B5EF4-FFF2-40B4-BE49-F238E27FC236}">
-                <a16:creationId xmlns:a16="http://schemas.microsoft.com/office/drawing/2014/main" id="{88AD9559-7D78-4BF2-B077-A782EBDC8018}"/>
+                <a16:creationId xmlns:a16="http://schemas.microsoft.com/office/drawing/2014/main" id="{D954DEE7-1BA8-465B-8EE8-4422A9C470C1}"/>
               </a:ext>
             </a:extLst>
           </p:cNvPr>
@@ -2436,7 +2451,7 @@
           <p:cNvPr id="3" name="slide-2-title-rule">
             <a:extLst xmlns:a="http://schemas.openxmlformats.org/drawingml/2006/main">
               <a:ext uri="{FF2B5EF4-FFF2-40B4-BE49-F238E27FC236}">
-                <a16:creationId xmlns:a16="http://schemas.microsoft.com/office/drawing/2014/main" id="{475FD293-088D-4E92-B176-FC993D88BB9F}"/>
+                <a16:creationId xmlns:a16="http://schemas.microsoft.com/office/drawing/2014/main" id="{1BD65DEF-E3E3-4139-BEA1-DEB31E5D3424}"/>
               </a:ext>
             </a:extLst>
           </p:cNvPr>
@@ -2467,7 +2482,7 @@
           <p:cNvPr id="4" name="problem-left-kicker">
             <a:extLst xmlns:a="http://schemas.openxmlformats.org/drawingml/2006/main">
               <a:ext uri="{FF2B5EF4-FFF2-40B4-BE49-F238E27FC236}">
-                <a16:creationId xmlns:a16="http://schemas.microsoft.com/office/drawing/2014/main" id="{6C8F620A-58BA-4215-A3DC-168E9F73CA50}"/>
+                <a16:creationId xmlns:a16="http://schemas.microsoft.com/office/drawing/2014/main" id="{08D44BAB-DD86-4333-B6D8-1BBF18C96579}"/>
               </a:ext>
             </a:extLst>
           </p:cNvPr>
@@ -2529,7 +2544,7 @@
           <p:cNvPr id="5" name="problem-left-message">
             <a:extLst xmlns:a="http://schemas.openxmlformats.org/drawingml/2006/main">
               <a:ext uri="{FF2B5EF4-FFF2-40B4-BE49-F238E27FC236}">
-                <a16:creationId xmlns:a16="http://schemas.microsoft.com/office/drawing/2014/main" id="{B3AC11FB-6655-4909-9A2C-FABDE3E7F389}"/>
+                <a16:creationId xmlns:a16="http://schemas.microsoft.com/office/drawing/2014/main" id="{BF45B311-565B-4FD7-B16C-762DF0CE07CD}"/>
               </a:ext>
             </a:extLst>
           </p:cNvPr>
@@ -2581,7 +2596,7 @@
                 <a:ea typeface="Apple SD Gothic Neo"/>
                 <a:cs typeface="Apple SD Gothic Neo"/>
               </a:rPr>
-              <a:t>고객이 가진 자산</a:t>
+              <a:t>고객이 보유한 지원 자산</a:t>
             </a:r>
           </a:p>
           <a:p xmlns:a="http://schemas.openxmlformats.org/drawingml/2006/main">
@@ -2645,7 +2660,7 @@
           <p:cNvPr id="6" name="problem-left-consequence">
             <a:extLst xmlns:a="http://schemas.openxmlformats.org/drawingml/2006/main">
               <a:ext uri="{FF2B5EF4-FFF2-40B4-BE49-F238E27FC236}">
-                <a16:creationId xmlns:a16="http://schemas.microsoft.com/office/drawing/2014/main" id="{83DA91F7-9F48-4516-B16D-CB93DE779E81}"/>
+                <a16:creationId xmlns:a16="http://schemas.microsoft.com/office/drawing/2014/main" id="{21CBD937-1C10-4BF3-8B5B-1FBD088E2E3B}"/>
               </a:ext>
             </a:extLst>
           </p:cNvPr>
@@ -2707,7 +2722,7 @@
           <p:cNvPr id="7" name="problem-vertical-rule">
             <a:extLst xmlns:a="http://schemas.openxmlformats.org/drawingml/2006/main">
               <a:ext uri="{FF2B5EF4-FFF2-40B4-BE49-F238E27FC236}">
-                <a16:creationId xmlns:a16="http://schemas.microsoft.com/office/drawing/2014/main" id="{005C7CF4-D909-4830-AA0C-F14ACD9E81AC}"/>
+                <a16:creationId xmlns:a16="http://schemas.microsoft.com/office/drawing/2014/main" id="{239B05A8-33A4-4126-84E8-BE62F7F7AE5F}"/>
               </a:ext>
             </a:extLst>
           </p:cNvPr>
@@ -2738,7 +2753,7 @@
           <p:cNvPr id="8" name="problem-risk-num-0">
             <a:extLst xmlns:a="http://schemas.openxmlformats.org/drawingml/2006/main">
               <a:ext uri="{FF2B5EF4-FFF2-40B4-BE49-F238E27FC236}">
-                <a16:creationId xmlns:a16="http://schemas.microsoft.com/office/drawing/2014/main" id="{0DA6D1BF-6A08-4EAC-8E40-45CA464143E4}"/>
+                <a16:creationId xmlns:a16="http://schemas.microsoft.com/office/drawing/2014/main" id="{36B354A6-91A1-40C4-B157-ED0021724C54}"/>
               </a:ext>
             </a:extLst>
           </p:cNvPr>
@@ -2800,7 +2815,7 @@
           <p:cNvPr id="9" name="problem-risk-title-0">
             <a:extLst xmlns:a="http://schemas.openxmlformats.org/drawingml/2006/main">
               <a:ext uri="{FF2B5EF4-FFF2-40B4-BE49-F238E27FC236}">
-                <a16:creationId xmlns:a16="http://schemas.microsoft.com/office/drawing/2014/main" id="{C6AB4A6D-2337-4F6B-A419-FD687177D62B}"/>
+                <a16:creationId xmlns:a16="http://schemas.microsoft.com/office/drawing/2014/main" id="{154A36B4-7F93-4B5F-9B62-792D5F07996B}"/>
               </a:ext>
             </a:extLst>
           </p:cNvPr>
@@ -2862,7 +2877,7 @@
           <p:cNvPr id="10" name="problem-risk-body-0">
             <a:extLst xmlns:a="http://schemas.openxmlformats.org/drawingml/2006/main">
               <a:ext uri="{FF2B5EF4-FFF2-40B4-BE49-F238E27FC236}">
-                <a16:creationId xmlns:a16="http://schemas.microsoft.com/office/drawing/2014/main" id="{D1548F74-9C59-42DA-BD6F-8C448BE8D570}"/>
+                <a16:creationId xmlns:a16="http://schemas.microsoft.com/office/drawing/2014/main" id="{7C64DB2A-6D97-4FAC-8223-8A30073BCE08}"/>
               </a:ext>
             </a:extLst>
           </p:cNvPr>
@@ -2924,7 +2939,7 @@
           <p:cNvPr id="11" name="problem-risk-rule-0">
             <a:extLst xmlns:a="http://schemas.openxmlformats.org/drawingml/2006/main">
               <a:ext uri="{FF2B5EF4-FFF2-40B4-BE49-F238E27FC236}">
-                <a16:creationId xmlns:a16="http://schemas.microsoft.com/office/drawing/2014/main" id="{71752EC7-371A-43AC-B986-90CCECA74CEC}"/>
+                <a16:creationId xmlns:a16="http://schemas.microsoft.com/office/drawing/2014/main" id="{7699AA2C-127B-42E9-9C98-AF20B7A252ED}"/>
               </a:ext>
             </a:extLst>
           </p:cNvPr>
@@ -2955,7 +2970,7 @@
           <p:cNvPr id="12" name="problem-risk-num-1">
             <a:extLst xmlns:a="http://schemas.openxmlformats.org/drawingml/2006/main">
               <a:ext uri="{FF2B5EF4-FFF2-40B4-BE49-F238E27FC236}">
-                <a16:creationId xmlns:a16="http://schemas.microsoft.com/office/drawing/2014/main" id="{703B61AF-447A-449E-AE33-F7B606E131E3}"/>
+                <a16:creationId xmlns:a16="http://schemas.microsoft.com/office/drawing/2014/main" id="{74686399-5190-4FDD-9B17-7F70AC25B627}"/>
               </a:ext>
             </a:extLst>
           </p:cNvPr>
@@ -3017,7 +3032,7 @@
           <p:cNvPr id="13" name="problem-risk-title-1">
             <a:extLst xmlns:a="http://schemas.openxmlformats.org/drawingml/2006/main">
               <a:ext uri="{FF2B5EF4-FFF2-40B4-BE49-F238E27FC236}">
-                <a16:creationId xmlns:a16="http://schemas.microsoft.com/office/drawing/2014/main" id="{E778C8BC-DFB6-4614-8B95-CCE97EFC121B}"/>
+                <a16:creationId xmlns:a16="http://schemas.microsoft.com/office/drawing/2014/main" id="{1ECF122C-62D9-4FFC-870E-82DE81A6375C}"/>
               </a:ext>
             </a:extLst>
           </p:cNvPr>
@@ -3079,7 +3094,7 @@
           <p:cNvPr id="14" name="problem-risk-body-1">
             <a:extLst xmlns:a="http://schemas.openxmlformats.org/drawingml/2006/main">
               <a:ext uri="{FF2B5EF4-FFF2-40B4-BE49-F238E27FC236}">
-                <a16:creationId xmlns:a16="http://schemas.microsoft.com/office/drawing/2014/main" id="{1FE6AD91-2CEF-41BA-BC69-F450310CA3C0}"/>
+                <a16:creationId xmlns:a16="http://schemas.microsoft.com/office/drawing/2014/main" id="{F92EF918-057F-4B58-ABA5-99993D8B6F79}"/>
               </a:ext>
             </a:extLst>
           </p:cNvPr>
@@ -3141,7 +3156,7 @@
           <p:cNvPr id="15" name="problem-risk-rule-1">
             <a:extLst xmlns:a="http://schemas.openxmlformats.org/drawingml/2006/main">
               <a:ext uri="{FF2B5EF4-FFF2-40B4-BE49-F238E27FC236}">
-                <a16:creationId xmlns:a16="http://schemas.microsoft.com/office/drawing/2014/main" id="{7B6F6F00-4A8D-4E27-BF5D-1FBF2ED010DB}"/>
+                <a16:creationId xmlns:a16="http://schemas.microsoft.com/office/drawing/2014/main" id="{8EA9DFEB-8BC9-49CA-847A-66B44349E0FA}"/>
               </a:ext>
             </a:extLst>
           </p:cNvPr>
@@ -3172,7 +3187,7 @@
           <p:cNvPr id="16" name="problem-risk-num-2">
             <a:extLst xmlns:a="http://schemas.openxmlformats.org/drawingml/2006/main">
               <a:ext uri="{FF2B5EF4-FFF2-40B4-BE49-F238E27FC236}">
-                <a16:creationId xmlns:a16="http://schemas.microsoft.com/office/drawing/2014/main" id="{CED1F7C6-D139-48D8-B9A5-B0DA14D9A10E}"/>
+                <a16:creationId xmlns:a16="http://schemas.microsoft.com/office/drawing/2014/main" id="{E2108F93-A239-44AC-980F-2C629F6CEFD2}"/>
               </a:ext>
             </a:extLst>
           </p:cNvPr>
@@ -3234,7 +3249,7 @@
           <p:cNvPr id="17" name="problem-risk-title-2">
             <a:extLst xmlns:a="http://schemas.openxmlformats.org/drawingml/2006/main">
               <a:ext uri="{FF2B5EF4-FFF2-40B4-BE49-F238E27FC236}">
-                <a16:creationId xmlns:a16="http://schemas.microsoft.com/office/drawing/2014/main" id="{D400BB0D-8FB7-4633-B5F1-DEF08F2129AC}"/>
+                <a16:creationId xmlns:a16="http://schemas.microsoft.com/office/drawing/2014/main" id="{4585CCAC-2323-4D52-B2CC-C8B3BC1DD5D7}"/>
               </a:ext>
             </a:extLst>
           </p:cNvPr>
@@ -3296,7 +3311,7 @@
           <p:cNvPr id="18" name="problem-risk-body-2">
             <a:extLst xmlns:a="http://schemas.openxmlformats.org/drawingml/2006/main">
               <a:ext uri="{FF2B5EF4-FFF2-40B4-BE49-F238E27FC236}">
-                <a16:creationId xmlns:a16="http://schemas.microsoft.com/office/drawing/2014/main" id="{A6AD8FC9-5FCB-4A42-AFC1-666A8AF50632}"/>
+                <a16:creationId xmlns:a16="http://schemas.microsoft.com/office/drawing/2014/main" id="{4709530B-5B80-4493-BBE1-70AE21200ACA}"/>
               </a:ext>
             </a:extLst>
           </p:cNvPr>
@@ -3358,7 +3373,7 @@
           <p:cNvPr id="19" name="footer-label-2">
             <a:extLst xmlns:a="http://schemas.openxmlformats.org/drawingml/2006/main">
               <a:ext uri="{FF2B5EF4-FFF2-40B4-BE49-F238E27FC236}">
-                <a16:creationId xmlns:a16="http://schemas.microsoft.com/office/drawing/2014/main" id="{504A9A84-39D3-48C8-B062-85481AF25681}"/>
+                <a16:creationId xmlns:a16="http://schemas.microsoft.com/office/drawing/2014/main" id="{31A21106-BCF4-4786-A70B-42EEAAC4AA41}"/>
               </a:ext>
             </a:extLst>
           </p:cNvPr>
@@ -3420,7 +3435,7 @@
           <p:cNvPr id="20" name="footer-page-2">
             <a:extLst xmlns:a="http://schemas.openxmlformats.org/drawingml/2006/main">
               <a:ext uri="{FF2B5EF4-FFF2-40B4-BE49-F238E27FC236}">
-                <a16:creationId xmlns:a16="http://schemas.microsoft.com/office/drawing/2014/main" id="{6A6D5E36-FEBA-4CEC-A999-806B2B7FC80B}"/>
+                <a16:creationId xmlns:a16="http://schemas.microsoft.com/office/drawing/2014/main" id="{95EBCD80-FF95-4983-BC4C-F5A76CC0DDD1}"/>
               </a:ext>
             </a:extLst>
           </p:cNvPr>
@@ -3480,7 +3495,7 @@
     </p:spTree>
     <p:extLst>
       <p:ext uri="{BB962C8B-B14F-4D97-AF65-F5344CB8AC3E}">
-        <p14:creationId xmlns:p14="http://schemas.microsoft.com/office/powerpoint/2010/main" val="651867817"/>
+        <p14:creationId xmlns:p14="http://schemas.microsoft.com/office/powerpoint/2010/main" val="656360911"/>
       </p:ext>
     </p:extLst>
   </p:cSld>
@@ -3511,7 +3526,7 @@
           <p:cNvPr id="22" name="slide-3-title">
             <a:extLst xmlns:a="http://schemas.openxmlformats.org/drawingml/2006/main">
               <a:ext uri="{FF2B5EF4-FFF2-40B4-BE49-F238E27FC236}">
-                <a16:creationId xmlns:a16="http://schemas.microsoft.com/office/drawing/2014/main" id="{93F0C094-2131-4617-85D1-FD54D3B9257E}"/>
+                <a16:creationId xmlns:a16="http://schemas.microsoft.com/office/drawing/2014/main" id="{1CF9C6AD-B09C-49CC-9106-270E05E51B83}"/>
               </a:ext>
             </a:extLst>
           </p:cNvPr>
@@ -3573,7 +3588,7 @@
           <p:cNvPr id="2" name="slide-3-subtitle">
             <a:extLst xmlns:a="http://schemas.openxmlformats.org/drawingml/2006/main">
               <a:ext uri="{FF2B5EF4-FFF2-40B4-BE49-F238E27FC236}">
-                <a16:creationId xmlns:a16="http://schemas.microsoft.com/office/drawing/2014/main" id="{18E21FF0-AFCC-4947-B9FE-1E2A18698956}"/>
+                <a16:creationId xmlns:a16="http://schemas.microsoft.com/office/drawing/2014/main" id="{EB8E09A2-0FE3-4E91-A35C-EFC769190835}"/>
               </a:ext>
             </a:extLst>
           </p:cNvPr>
@@ -3635,7 +3650,7 @@
           <p:cNvPr id="3" name="slide-3-title-rule">
             <a:extLst xmlns:a="http://schemas.openxmlformats.org/drawingml/2006/main">
               <a:ext uri="{FF2B5EF4-FFF2-40B4-BE49-F238E27FC236}">
-                <a16:creationId xmlns:a16="http://schemas.microsoft.com/office/drawing/2014/main" id="{05FFF35B-633E-4668-81DB-96D9097FCA53}"/>
+                <a16:creationId xmlns:a16="http://schemas.microsoft.com/office/drawing/2014/main" id="{0518BFB9-8531-48D1-B605-8E065FCDB273}"/>
               </a:ext>
             </a:extLst>
           </p:cNvPr>
@@ -3666,7 +3681,7 @@
           <p:cNvPr id="4" name="solution-connector-1">
             <a:extLst xmlns:a="http://schemas.openxmlformats.org/drawingml/2006/main">
               <a:ext uri="{FF2B5EF4-FFF2-40B4-BE49-F238E27FC236}">
-                <a16:creationId xmlns:a16="http://schemas.microsoft.com/office/drawing/2014/main" id="{FAED2DE0-A016-4A63-B4E2-8BC25E2EA646}"/>
+                <a16:creationId xmlns:a16="http://schemas.microsoft.com/office/drawing/2014/main" id="{6014A84B-C6EB-417F-B184-64FA34BB576D}"/>
               </a:ext>
             </a:extLst>
           </p:cNvPr>
@@ -3697,7 +3712,7 @@
           <p:cNvPr id="5" name="solution-connector-2">
             <a:extLst xmlns:a="http://schemas.openxmlformats.org/drawingml/2006/main">
               <a:ext uri="{FF2B5EF4-FFF2-40B4-BE49-F238E27FC236}">
-                <a16:creationId xmlns:a16="http://schemas.microsoft.com/office/drawing/2014/main" id="{DF52EFAC-31D8-41D7-A30C-F451C20E6C40}"/>
+                <a16:creationId xmlns:a16="http://schemas.microsoft.com/office/drawing/2014/main" id="{2209962B-ACF5-4891-AD71-094A8A94B906}"/>
               </a:ext>
             </a:extLst>
           </p:cNvPr>
@@ -3728,7 +3743,7 @@
           <p:cNvPr id="6" name="solution-node-0">
             <a:extLst xmlns:a="http://schemas.openxmlformats.org/drawingml/2006/main">
               <a:ext uri="{FF2B5EF4-FFF2-40B4-BE49-F238E27FC236}">
-                <a16:creationId xmlns:a16="http://schemas.microsoft.com/office/drawing/2014/main" id="{DF7F5B0C-C01E-4292-B310-F9EE20C27C9A}"/>
+                <a16:creationId xmlns:a16="http://schemas.microsoft.com/office/drawing/2014/main" id="{AD802594-1009-4CE6-9663-0D0EBEAF6F87}"/>
               </a:ext>
             </a:extLst>
           </p:cNvPr>
@@ -3759,7 +3774,7 @@
           <p:cNvPr id="7" name="solution-node-number-0">
             <a:extLst xmlns:a="http://schemas.openxmlformats.org/drawingml/2006/main">
               <a:ext uri="{FF2B5EF4-FFF2-40B4-BE49-F238E27FC236}">
-                <a16:creationId xmlns:a16="http://schemas.microsoft.com/office/drawing/2014/main" id="{EFBBE3D7-11BC-4E43-93C6-B9B94EF2374F}"/>
+                <a16:creationId xmlns:a16="http://schemas.microsoft.com/office/drawing/2014/main" id="{7A49687A-2BF8-45B8-A19C-A7D58BC25178}"/>
               </a:ext>
             </a:extLst>
           </p:cNvPr>
@@ -3821,7 +3836,7 @@
           <p:cNvPr id="8" name="solution-node-1">
             <a:extLst xmlns:a="http://schemas.openxmlformats.org/drawingml/2006/main">
               <a:ext uri="{FF2B5EF4-FFF2-40B4-BE49-F238E27FC236}">
-                <a16:creationId xmlns:a16="http://schemas.microsoft.com/office/drawing/2014/main" id="{070B5A12-C664-496C-8741-6F8C5802A46C}"/>
+                <a16:creationId xmlns:a16="http://schemas.microsoft.com/office/drawing/2014/main" id="{5F4EF460-6B69-431E-9A4A-27B8BEE00BA3}"/>
               </a:ext>
             </a:extLst>
           </p:cNvPr>
@@ -3852,7 +3867,7 @@
           <p:cNvPr id="9" name="solution-node-number-1">
             <a:extLst xmlns:a="http://schemas.openxmlformats.org/drawingml/2006/main">
               <a:ext uri="{FF2B5EF4-FFF2-40B4-BE49-F238E27FC236}">
-                <a16:creationId xmlns:a16="http://schemas.microsoft.com/office/drawing/2014/main" id="{46CBE70C-8A1C-44C1-A93A-EE33C762A983}"/>
+                <a16:creationId xmlns:a16="http://schemas.microsoft.com/office/drawing/2014/main" id="{EEADE0E8-8AA7-4D74-A11C-89D23B8C6FD1}"/>
               </a:ext>
             </a:extLst>
           </p:cNvPr>
@@ -3914,7 +3929,7 @@
           <p:cNvPr id="10" name="solution-node-2">
             <a:extLst xmlns:a="http://schemas.openxmlformats.org/drawingml/2006/main">
               <a:ext uri="{FF2B5EF4-FFF2-40B4-BE49-F238E27FC236}">
-                <a16:creationId xmlns:a16="http://schemas.microsoft.com/office/drawing/2014/main" id="{177EC261-E77D-4F73-84ED-AF0333731497}"/>
+                <a16:creationId xmlns:a16="http://schemas.microsoft.com/office/drawing/2014/main" id="{F41B8A20-06D8-4C26-953A-EBB5253F2245}"/>
               </a:ext>
             </a:extLst>
           </p:cNvPr>
@@ -3945,7 +3960,7 @@
           <p:cNvPr id="11" name="solution-node-number-2">
             <a:extLst xmlns:a="http://schemas.openxmlformats.org/drawingml/2006/main">
               <a:ext uri="{FF2B5EF4-FFF2-40B4-BE49-F238E27FC236}">
-                <a16:creationId xmlns:a16="http://schemas.microsoft.com/office/drawing/2014/main" id="{884D6B7F-99E4-413A-B3B7-19AD285F3056}"/>
+                <a16:creationId xmlns:a16="http://schemas.microsoft.com/office/drawing/2014/main" id="{8B70A314-D68F-48ED-8782-6CF11CF219EE}"/>
               </a:ext>
             </a:extLst>
           </p:cNvPr>
@@ -4007,7 +4022,7 @@
           <p:cNvPr id="12" name="solution-step-title-0">
             <a:extLst xmlns:a="http://schemas.openxmlformats.org/drawingml/2006/main">
               <a:ext uri="{FF2B5EF4-FFF2-40B4-BE49-F238E27FC236}">
-                <a16:creationId xmlns:a16="http://schemas.microsoft.com/office/drawing/2014/main" id="{806253C7-24F9-450F-AF4E-CE66D4A735BE}"/>
+                <a16:creationId xmlns:a16="http://schemas.microsoft.com/office/drawing/2014/main" id="{7DC4C20D-3929-49A1-9EF9-BF0337EAD9A9}"/>
               </a:ext>
             </a:extLst>
           </p:cNvPr>
@@ -4069,7 +4084,7 @@
           <p:cNvPr id="13" name="solution-step-body-0">
             <a:extLst xmlns:a="http://schemas.openxmlformats.org/drawingml/2006/main">
               <a:ext uri="{FF2B5EF4-FFF2-40B4-BE49-F238E27FC236}">
-                <a16:creationId xmlns:a16="http://schemas.microsoft.com/office/drawing/2014/main" id="{7DF967AE-869C-4737-91FA-CAF23BAB8D42}"/>
+                <a16:creationId xmlns:a16="http://schemas.microsoft.com/office/drawing/2014/main" id="{00EF7CC6-0B78-45A6-96EA-094553A89AEF}"/>
               </a:ext>
             </a:extLst>
           </p:cNvPr>
@@ -4131,7 +4146,7 @@
           <p:cNvPr id="14" name="solution-step-title-1">
             <a:extLst xmlns:a="http://schemas.openxmlformats.org/drawingml/2006/main">
               <a:ext uri="{FF2B5EF4-FFF2-40B4-BE49-F238E27FC236}">
-                <a16:creationId xmlns:a16="http://schemas.microsoft.com/office/drawing/2014/main" id="{9B2B6F9F-B413-4EFC-893C-3F2B015F11E0}"/>
+                <a16:creationId xmlns:a16="http://schemas.microsoft.com/office/drawing/2014/main" id="{A5D1AB7B-50CD-4EE9-9A28-7838B74BDBF6}"/>
               </a:ext>
             </a:extLst>
           </p:cNvPr>
@@ -4193,7 +4208,7 @@
           <p:cNvPr id="15" name="solution-step-body-1">
             <a:extLst xmlns:a="http://schemas.openxmlformats.org/drawingml/2006/main">
               <a:ext uri="{FF2B5EF4-FFF2-40B4-BE49-F238E27FC236}">
-                <a16:creationId xmlns:a16="http://schemas.microsoft.com/office/drawing/2014/main" id="{3A7CE41F-4025-4E7D-87CF-560F6AEC788A}"/>
+                <a16:creationId xmlns:a16="http://schemas.microsoft.com/office/drawing/2014/main" id="{1A4DBFC6-CC14-4DAA-BC4F-7A7CB4FC3019}"/>
               </a:ext>
             </a:extLst>
           </p:cNvPr>
@@ -4255,7 +4270,7 @@
           <p:cNvPr id="16" name="solution-step-title-2">
             <a:extLst xmlns:a="http://schemas.openxmlformats.org/drawingml/2006/main">
               <a:ext uri="{FF2B5EF4-FFF2-40B4-BE49-F238E27FC236}">
-                <a16:creationId xmlns:a16="http://schemas.microsoft.com/office/drawing/2014/main" id="{CB3C1349-9779-4902-A699-668137C36D0A}"/>
+                <a16:creationId xmlns:a16="http://schemas.microsoft.com/office/drawing/2014/main" id="{B5D0DD8E-B47A-4D1A-BF3E-48FE8FCD990B}"/>
               </a:ext>
             </a:extLst>
           </p:cNvPr>
@@ -4317,7 +4332,7 @@
           <p:cNvPr id="17" name="solution-step-body-2">
             <a:extLst xmlns:a="http://schemas.openxmlformats.org/drawingml/2006/main">
               <a:ext uri="{FF2B5EF4-FFF2-40B4-BE49-F238E27FC236}">
-                <a16:creationId xmlns:a16="http://schemas.microsoft.com/office/drawing/2014/main" id="{182F3E52-B09D-4A0D-8A61-29C8C5EE44D4}"/>
+                <a16:creationId xmlns:a16="http://schemas.microsoft.com/office/drawing/2014/main" id="{F421C020-CF70-4E0E-912B-C88CA85DEFD5}"/>
               </a:ext>
             </a:extLst>
           </p:cNvPr>
@@ -4379,7 +4394,7 @@
           <p:cNvPr id="18" name="solution-zero-balance-bg">
             <a:extLst xmlns:a="http://schemas.openxmlformats.org/drawingml/2006/main">
               <a:ext uri="{FF2B5EF4-FFF2-40B4-BE49-F238E27FC236}">
-                <a16:creationId xmlns:a16="http://schemas.microsoft.com/office/drawing/2014/main" id="{3DC289D7-0B49-431D-B1C2-BFF9E8E005D6}"/>
+                <a16:creationId xmlns:a16="http://schemas.microsoft.com/office/drawing/2014/main" id="{AE301BA1-FDFD-4081-9F6A-3760FA625D10}"/>
               </a:ext>
             </a:extLst>
           </p:cNvPr>
@@ -4410,7 +4425,7 @@
           <p:cNvPr id="19" name="solution-zero-balance">
             <a:extLst xmlns:a="http://schemas.openxmlformats.org/drawingml/2006/main">
               <a:ext uri="{FF2B5EF4-FFF2-40B4-BE49-F238E27FC236}">
-                <a16:creationId xmlns:a16="http://schemas.microsoft.com/office/drawing/2014/main" id="{A785EB72-D4CC-4D7F-83BB-8A50AAB6ABB9}"/>
+                <a16:creationId xmlns:a16="http://schemas.microsoft.com/office/drawing/2014/main" id="{3CFE3BA2-F392-4F82-A1A2-544536199FC7}"/>
               </a:ext>
             </a:extLst>
           </p:cNvPr>
@@ -4472,7 +4487,7 @@
           <p:cNvPr id="20" name="footer-label-3">
             <a:extLst xmlns:a="http://schemas.openxmlformats.org/drawingml/2006/main">
               <a:ext uri="{FF2B5EF4-FFF2-40B4-BE49-F238E27FC236}">
-                <a16:creationId xmlns:a16="http://schemas.microsoft.com/office/drawing/2014/main" id="{A38EE101-2A74-4B9B-BEA0-FE73E8101C33}"/>
+                <a16:creationId xmlns:a16="http://schemas.microsoft.com/office/drawing/2014/main" id="{B236D70B-B77A-4355-BE76-B8BFFF3ECD36}"/>
               </a:ext>
             </a:extLst>
           </p:cNvPr>
@@ -4534,7 +4549,7 @@
           <p:cNvPr id="21" name="footer-page-3">
             <a:extLst xmlns:a="http://schemas.openxmlformats.org/drawingml/2006/main">
               <a:ext uri="{FF2B5EF4-FFF2-40B4-BE49-F238E27FC236}">
-                <a16:creationId xmlns:a16="http://schemas.microsoft.com/office/drawing/2014/main" id="{17999305-C31F-459C-B57B-ABC5F312DD1A}"/>
+                <a16:creationId xmlns:a16="http://schemas.microsoft.com/office/drawing/2014/main" id="{C3400C25-C06D-49E0-8B46-D627B0F160E8}"/>
               </a:ext>
             </a:extLst>
           </p:cNvPr>
@@ -4594,7 +4609,7 @@
     </p:spTree>
     <p:extLst>
       <p:ext uri="{BB962C8B-B14F-4D97-AF65-F5344CB8AC3E}">
-        <p14:creationId xmlns:p14="http://schemas.microsoft.com/office/powerpoint/2010/main" val="117377647"/>
+        <p14:creationId xmlns:p14="http://schemas.microsoft.com/office/powerpoint/2010/main" val="1337261718"/>
       </p:ext>
     </p:extLst>
   </p:cSld>
@@ -4625,7 +4640,7 @@
           <p:cNvPr id="20" name="slide-4-title">
             <a:extLst xmlns:a="http://schemas.openxmlformats.org/drawingml/2006/main">
               <a:ext uri="{FF2B5EF4-FFF2-40B4-BE49-F238E27FC236}">
-                <a16:creationId xmlns:a16="http://schemas.microsoft.com/office/drawing/2014/main" id="{AAC46C8C-F221-492B-8096-73DC7C5E0FF6}"/>
+                <a16:creationId xmlns:a16="http://schemas.microsoft.com/office/drawing/2014/main" id="{5B22144E-A878-49FC-B39E-743A96B02F16}"/>
               </a:ext>
             </a:extLst>
           </p:cNvPr>
@@ -4687,7 +4702,7 @@
           <p:cNvPr id="2" name="slide-4-subtitle">
             <a:extLst xmlns:a="http://schemas.openxmlformats.org/drawingml/2006/main">
               <a:ext uri="{FF2B5EF4-FFF2-40B4-BE49-F238E27FC236}">
-                <a16:creationId xmlns:a16="http://schemas.microsoft.com/office/drawing/2014/main" id="{D3B2DFB5-5FFE-470D-9179-A32FAF6C1C6F}"/>
+                <a16:creationId xmlns:a16="http://schemas.microsoft.com/office/drawing/2014/main" id="{A264FDDA-B61C-4385-88D5-82CEC8AB72DD}"/>
               </a:ext>
             </a:extLst>
           </p:cNvPr>
@@ -4749,7 +4764,7 @@
           <p:cNvPr id="3" name="slide-4-title-rule">
             <a:extLst xmlns:a="http://schemas.openxmlformats.org/drawingml/2006/main">
               <a:ext uri="{FF2B5EF4-FFF2-40B4-BE49-F238E27FC236}">
-                <a16:creationId xmlns:a16="http://schemas.microsoft.com/office/drawing/2014/main" id="{0ACEEC41-F0CF-411F-867C-B5969771D13E}"/>
+                <a16:creationId xmlns:a16="http://schemas.microsoft.com/office/drawing/2014/main" id="{BCFD5D35-BB9F-4460-BE71-4995AB9704E4}"/>
               </a:ext>
             </a:extLst>
           </p:cNvPr>
@@ -4780,7 +4795,7 @@
           <p:cNvPr id="4" name="giwa-label-0">
             <a:extLst xmlns:a="http://schemas.openxmlformats.org/drawingml/2006/main">
               <a:ext uri="{FF2B5EF4-FFF2-40B4-BE49-F238E27FC236}">
-                <a16:creationId xmlns:a16="http://schemas.microsoft.com/office/drawing/2014/main" id="{12F01045-CF0B-4730-A38F-3B50E49B4AE1}"/>
+                <a16:creationId xmlns:a16="http://schemas.microsoft.com/office/drawing/2014/main" id="{D0DD0F25-1304-4EC2-912E-4D58DC0EE8C5}"/>
               </a:ext>
             </a:extLst>
           </p:cNvPr>
@@ -4842,7 +4857,7 @@
           <p:cNvPr id="5" name="giwa-title-0">
             <a:extLst xmlns:a="http://schemas.openxmlformats.org/drawingml/2006/main">
               <a:ext uri="{FF2B5EF4-FFF2-40B4-BE49-F238E27FC236}">
-                <a16:creationId xmlns:a16="http://schemas.microsoft.com/office/drawing/2014/main" id="{6BA747CA-C4DE-41E9-AFF0-582229D50CDA}"/>
+                <a16:creationId xmlns:a16="http://schemas.microsoft.com/office/drawing/2014/main" id="{4493B7D7-7DB4-4528-91F1-E274FEB53DAE}"/>
               </a:ext>
             </a:extLst>
           </p:cNvPr>
@@ -4904,7 +4919,7 @@
           <p:cNvPr id="6" name="giwa-rule-0">
             <a:extLst xmlns:a="http://schemas.openxmlformats.org/drawingml/2006/main">
               <a:ext uri="{FF2B5EF4-FFF2-40B4-BE49-F238E27FC236}">
-                <a16:creationId xmlns:a16="http://schemas.microsoft.com/office/drawing/2014/main" id="{2ACC085B-5390-46D9-BBBB-51124C96CF46}"/>
+                <a16:creationId xmlns:a16="http://schemas.microsoft.com/office/drawing/2014/main" id="{EAABBCBF-1DAF-437D-9594-BF7DE966B06A}"/>
               </a:ext>
             </a:extLst>
           </p:cNvPr>
@@ -4935,7 +4950,7 @@
           <p:cNvPr id="7" name="giwa-body-0">
             <a:extLst xmlns:a="http://schemas.openxmlformats.org/drawingml/2006/main">
               <a:ext uri="{FF2B5EF4-FFF2-40B4-BE49-F238E27FC236}">
-                <a16:creationId xmlns:a16="http://schemas.microsoft.com/office/drawing/2014/main" id="{E9156867-2857-4764-9B03-699F0BDEBAFC}"/>
+                <a16:creationId xmlns:a16="http://schemas.microsoft.com/office/drawing/2014/main" id="{9EA86A26-0B5A-41FA-8D28-65B398301520}"/>
               </a:ext>
             </a:extLst>
           </p:cNvPr>
@@ -5029,7 +5044,7 @@
           <p:cNvPr id="8" name="giwa-label-1">
             <a:extLst xmlns:a="http://schemas.openxmlformats.org/drawingml/2006/main">
               <a:ext uri="{FF2B5EF4-FFF2-40B4-BE49-F238E27FC236}">
-                <a16:creationId xmlns:a16="http://schemas.microsoft.com/office/drawing/2014/main" id="{39973A33-1BA0-48FF-8497-E1612CDA39A8}"/>
+                <a16:creationId xmlns:a16="http://schemas.microsoft.com/office/drawing/2014/main" id="{6A393E47-1F2D-4D6A-BE62-3A4144B235DA}"/>
               </a:ext>
             </a:extLst>
           </p:cNvPr>
@@ -5091,7 +5106,7 @@
           <p:cNvPr id="9" name="giwa-title-1">
             <a:extLst xmlns:a="http://schemas.openxmlformats.org/drawingml/2006/main">
               <a:ext uri="{FF2B5EF4-FFF2-40B4-BE49-F238E27FC236}">
-                <a16:creationId xmlns:a16="http://schemas.microsoft.com/office/drawing/2014/main" id="{25003FC3-28D3-42AA-BC7D-15651317B373}"/>
+                <a16:creationId xmlns:a16="http://schemas.microsoft.com/office/drawing/2014/main" id="{6D6EEF6F-A65F-4088-800A-189F5AD2C2F3}"/>
               </a:ext>
             </a:extLst>
           </p:cNvPr>
@@ -5153,7 +5168,7 @@
           <p:cNvPr id="10" name="giwa-rule-1">
             <a:extLst xmlns:a="http://schemas.openxmlformats.org/drawingml/2006/main">
               <a:ext uri="{FF2B5EF4-FFF2-40B4-BE49-F238E27FC236}">
-                <a16:creationId xmlns:a16="http://schemas.microsoft.com/office/drawing/2014/main" id="{6FF92CA2-CFC9-4F40-A572-EFB642A570C4}"/>
+                <a16:creationId xmlns:a16="http://schemas.microsoft.com/office/drawing/2014/main" id="{253BC7DD-BE7F-472E-864C-C306F9B5283B}"/>
               </a:ext>
             </a:extLst>
           </p:cNvPr>
@@ -5184,7 +5199,7 @@
           <p:cNvPr id="11" name="giwa-body-1">
             <a:extLst xmlns:a="http://schemas.openxmlformats.org/drawingml/2006/main">
               <a:ext uri="{FF2B5EF4-FFF2-40B4-BE49-F238E27FC236}">
-                <a16:creationId xmlns:a16="http://schemas.microsoft.com/office/drawing/2014/main" id="{3D664ACB-6E29-4C84-AA5A-AED9DBD061EE}"/>
+                <a16:creationId xmlns:a16="http://schemas.microsoft.com/office/drawing/2014/main" id="{B7140E99-33B6-4594-8F37-35D025800AFE}"/>
               </a:ext>
             </a:extLst>
           </p:cNvPr>
@@ -5278,7 +5293,7 @@
           <p:cNvPr id="12" name="giwa-label-2">
             <a:extLst xmlns:a="http://schemas.openxmlformats.org/drawingml/2006/main">
               <a:ext uri="{FF2B5EF4-FFF2-40B4-BE49-F238E27FC236}">
-                <a16:creationId xmlns:a16="http://schemas.microsoft.com/office/drawing/2014/main" id="{45622FE0-57DD-45E4-9D91-9175859FFA69}"/>
+                <a16:creationId xmlns:a16="http://schemas.microsoft.com/office/drawing/2014/main" id="{3AB80B17-0E45-45B2-84D4-AAF016CD2693}"/>
               </a:ext>
             </a:extLst>
           </p:cNvPr>
@@ -5340,7 +5355,7 @@
           <p:cNvPr id="13" name="giwa-title-2">
             <a:extLst xmlns:a="http://schemas.openxmlformats.org/drawingml/2006/main">
               <a:ext uri="{FF2B5EF4-FFF2-40B4-BE49-F238E27FC236}">
-                <a16:creationId xmlns:a16="http://schemas.microsoft.com/office/drawing/2014/main" id="{0241DCC7-2284-409C-9FC6-4BDFCA74B448}"/>
+                <a16:creationId xmlns:a16="http://schemas.microsoft.com/office/drawing/2014/main" id="{FFDB7CEF-B812-4443-9F7E-4FED99343C3C}"/>
               </a:ext>
             </a:extLst>
           </p:cNvPr>
@@ -5402,7 +5417,7 @@
           <p:cNvPr id="14" name="giwa-rule-2">
             <a:extLst xmlns:a="http://schemas.openxmlformats.org/drawingml/2006/main">
               <a:ext uri="{FF2B5EF4-FFF2-40B4-BE49-F238E27FC236}">
-                <a16:creationId xmlns:a16="http://schemas.microsoft.com/office/drawing/2014/main" id="{458D44A8-ADD9-4C5A-BC77-73BDF9CD6BE5}"/>
+                <a16:creationId xmlns:a16="http://schemas.microsoft.com/office/drawing/2014/main" id="{69755760-8EA0-41E7-BA04-B2EE03FB667E}"/>
               </a:ext>
             </a:extLst>
           </p:cNvPr>
@@ -5433,7 +5448,7 @@
           <p:cNvPr id="15" name="giwa-body-2">
             <a:extLst xmlns:a="http://schemas.openxmlformats.org/drawingml/2006/main">
               <a:ext uri="{FF2B5EF4-FFF2-40B4-BE49-F238E27FC236}">
-                <a16:creationId xmlns:a16="http://schemas.microsoft.com/office/drawing/2014/main" id="{E59F293C-58AE-4E7B-A749-B03898ADFAFA}"/>
+                <a16:creationId xmlns:a16="http://schemas.microsoft.com/office/drawing/2014/main" id="{83F437CC-9DAA-47B8-A59C-E557DFB3115A}"/>
               </a:ext>
             </a:extLst>
           </p:cNvPr>
@@ -5527,7 +5542,7 @@
           <p:cNvPr id="16" name="giwa-truth-bg">
             <a:extLst xmlns:a="http://schemas.openxmlformats.org/drawingml/2006/main">
               <a:ext uri="{FF2B5EF4-FFF2-40B4-BE49-F238E27FC236}">
-                <a16:creationId xmlns:a16="http://schemas.microsoft.com/office/drawing/2014/main" id="{592284B9-C709-4A46-A00C-0F15B97B713B}"/>
+                <a16:creationId xmlns:a16="http://schemas.microsoft.com/office/drawing/2014/main" id="{F5F93D3B-4918-4EA9-97DB-0472B697945A}"/>
               </a:ext>
             </a:extLst>
           </p:cNvPr>
@@ -5558,7 +5573,7 @@
           <p:cNvPr id="17" name="giwa-truth">
             <a:extLst xmlns:a="http://schemas.openxmlformats.org/drawingml/2006/main">
               <a:ext uri="{FF2B5EF4-FFF2-40B4-BE49-F238E27FC236}">
-                <a16:creationId xmlns:a16="http://schemas.microsoft.com/office/drawing/2014/main" id="{6D52A819-C8F6-4FED-9F7B-B14D614E8BAC}"/>
+                <a16:creationId xmlns:a16="http://schemas.microsoft.com/office/drawing/2014/main" id="{99F3CCF0-5005-4BB6-9171-A3AD9DCC98EE}"/>
               </a:ext>
             </a:extLst>
           </p:cNvPr>
@@ -5620,7 +5635,7 @@
           <p:cNvPr id="18" name="footer-label-4">
             <a:extLst xmlns:a="http://schemas.openxmlformats.org/drawingml/2006/main">
               <a:ext uri="{FF2B5EF4-FFF2-40B4-BE49-F238E27FC236}">
-                <a16:creationId xmlns:a16="http://schemas.microsoft.com/office/drawing/2014/main" id="{D02A4DB9-7906-4D4D-A0FD-91B07D9D21A5}"/>
+                <a16:creationId xmlns:a16="http://schemas.microsoft.com/office/drawing/2014/main" id="{9B660B0A-F7EC-4E26-93B1-16648C3E11F5}"/>
               </a:ext>
             </a:extLst>
           </p:cNvPr>
@@ -5682,7 +5697,7 @@
           <p:cNvPr id="19" name="footer-page-4">
             <a:extLst xmlns:a="http://schemas.openxmlformats.org/drawingml/2006/main">
               <a:ext uri="{FF2B5EF4-FFF2-40B4-BE49-F238E27FC236}">
-                <a16:creationId xmlns:a16="http://schemas.microsoft.com/office/drawing/2014/main" id="{831D98F5-C606-4F93-A8AC-C946F44AB2F9}"/>
+                <a16:creationId xmlns:a16="http://schemas.microsoft.com/office/drawing/2014/main" id="{6A6A503F-B6B0-43B3-98E2-983B65B14AE6}"/>
               </a:ext>
             </a:extLst>
           </p:cNvPr>
@@ -5742,7 +5757,7 @@
     </p:spTree>
     <p:extLst>
       <p:ext uri="{BB962C8B-B14F-4D97-AF65-F5344CB8AC3E}">
-        <p14:creationId xmlns:p14="http://schemas.microsoft.com/office/powerpoint/2010/main" val="299327331"/>
+        <p14:creationId xmlns:p14="http://schemas.microsoft.com/office/powerpoint/2010/main" val="229101513"/>
       </p:ext>
     </p:extLst>
   </p:cSld>
@@ -5773,7 +5788,7 @@
           <p:cNvPr id="27" name="slide-5-title">
             <a:extLst xmlns:a="http://schemas.openxmlformats.org/drawingml/2006/main">
               <a:ext uri="{FF2B5EF4-FFF2-40B4-BE49-F238E27FC236}">
-                <a16:creationId xmlns:a16="http://schemas.microsoft.com/office/drawing/2014/main" id="{38BDCDD9-4DC4-4628-AC3D-88386894AE88}"/>
+                <a16:creationId xmlns:a16="http://schemas.microsoft.com/office/drawing/2014/main" id="{E9195192-2FFD-486B-B967-E0A1743D0178}"/>
               </a:ext>
             </a:extLst>
           </p:cNvPr>
@@ -5835,7 +5850,7 @@
           <p:cNvPr id="2" name="slide-5-subtitle">
             <a:extLst xmlns:a="http://schemas.openxmlformats.org/drawingml/2006/main">
               <a:ext uri="{FF2B5EF4-FFF2-40B4-BE49-F238E27FC236}">
-                <a16:creationId xmlns:a16="http://schemas.microsoft.com/office/drawing/2014/main" id="{BE7A7EB6-6EE2-4370-BEF9-2FB4F5DA4F82}"/>
+                <a16:creationId xmlns:a16="http://schemas.microsoft.com/office/drawing/2014/main" id="{DF6A585E-AE5D-495F-98BD-F0B39C667BCA}"/>
               </a:ext>
             </a:extLst>
           </p:cNvPr>
@@ -5897,7 +5912,7 @@
           <p:cNvPr id="3" name="slide-5-title-rule">
             <a:extLst xmlns:a="http://schemas.openxmlformats.org/drawingml/2006/main">
               <a:ext uri="{FF2B5EF4-FFF2-40B4-BE49-F238E27FC236}">
-                <a16:creationId xmlns:a16="http://schemas.microsoft.com/office/drawing/2014/main" id="{8FFF33AD-53DF-495C-8741-198F363D0C36}"/>
+                <a16:creationId xmlns:a16="http://schemas.microsoft.com/office/drawing/2014/main" id="{9304D51C-E7DD-4E46-8F40-DE0688ECAB6B}"/>
               </a:ext>
             </a:extLst>
           </p:cNvPr>
@@ -5928,7 +5943,7 @@
           <p:cNvPr id="4" name="evidence-label">
             <a:extLst xmlns:a="http://schemas.openxmlformats.org/drawingml/2006/main">
               <a:ext uri="{FF2B5EF4-FFF2-40B4-BE49-F238E27FC236}">
-                <a16:creationId xmlns:a16="http://schemas.microsoft.com/office/drawing/2014/main" id="{0DA6A686-B41D-4A82-9373-D70125986B4E}"/>
+                <a16:creationId xmlns:a16="http://schemas.microsoft.com/office/drawing/2014/main" id="{958B66B6-8982-4285-90EB-E90D6ACA7539}"/>
               </a:ext>
             </a:extLst>
           </p:cNvPr>
@@ -5990,7 +6005,7 @@
           <p:cNvPr id="5" name="evidence-num-0">
             <a:extLst xmlns:a="http://schemas.openxmlformats.org/drawingml/2006/main">
               <a:ext uri="{FF2B5EF4-FFF2-40B4-BE49-F238E27FC236}">
-                <a16:creationId xmlns:a16="http://schemas.microsoft.com/office/drawing/2014/main" id="{8D7EFC6F-6B6E-4FE4-ADC9-F1D0C6E23BD5}"/>
+                <a16:creationId xmlns:a16="http://schemas.microsoft.com/office/drawing/2014/main" id="{DF55AA6D-5569-49A1-9398-9511056FD794}"/>
               </a:ext>
             </a:extLst>
           </p:cNvPr>
@@ -6052,7 +6067,7 @@
           <p:cNvPr id="6" name="evidence-title-0">
             <a:extLst xmlns:a="http://schemas.openxmlformats.org/drawingml/2006/main">
               <a:ext uri="{FF2B5EF4-FFF2-40B4-BE49-F238E27FC236}">
-                <a16:creationId xmlns:a16="http://schemas.microsoft.com/office/drawing/2014/main" id="{69FB5503-9429-44CF-A59A-E81B000E12C4}"/>
+                <a16:creationId xmlns:a16="http://schemas.microsoft.com/office/drawing/2014/main" id="{B153A69D-5D7E-4623-BF7D-E1DA38EA3667}"/>
               </a:ext>
             </a:extLst>
           </p:cNvPr>
@@ -6114,7 +6129,7 @@
           <p:cNvPr id="7" name="evidence-body-0">
             <a:extLst xmlns:a="http://schemas.openxmlformats.org/drawingml/2006/main">
               <a:ext uri="{FF2B5EF4-FFF2-40B4-BE49-F238E27FC236}">
-                <a16:creationId xmlns:a16="http://schemas.microsoft.com/office/drawing/2014/main" id="{8F2844B0-6585-4494-BE4A-A5FED1459EB0}"/>
+                <a16:creationId xmlns:a16="http://schemas.microsoft.com/office/drawing/2014/main" id="{718A8726-E6BA-4D56-8B9B-7A7FB9693130}"/>
               </a:ext>
             </a:extLst>
           </p:cNvPr>
@@ -6176,7 +6191,7 @@
           <p:cNvPr id="8" name="evidence-row-rule-0">
             <a:extLst xmlns:a="http://schemas.openxmlformats.org/drawingml/2006/main">
               <a:ext uri="{FF2B5EF4-FFF2-40B4-BE49-F238E27FC236}">
-                <a16:creationId xmlns:a16="http://schemas.microsoft.com/office/drawing/2014/main" id="{871AFD50-680D-4B14-BDF6-5EEE1ADF498B}"/>
+                <a16:creationId xmlns:a16="http://schemas.microsoft.com/office/drawing/2014/main" id="{ED1CB3F2-3968-41FC-82F8-63F7FE099197}"/>
               </a:ext>
             </a:extLst>
           </p:cNvPr>
@@ -6207,7 +6222,7 @@
           <p:cNvPr id="9" name="evidence-num-1">
             <a:extLst xmlns:a="http://schemas.openxmlformats.org/drawingml/2006/main">
               <a:ext uri="{FF2B5EF4-FFF2-40B4-BE49-F238E27FC236}">
-                <a16:creationId xmlns:a16="http://schemas.microsoft.com/office/drawing/2014/main" id="{4617C4DD-3BBD-4AC3-BFBA-7CD52367EBE5}"/>
+                <a16:creationId xmlns:a16="http://schemas.microsoft.com/office/drawing/2014/main" id="{01AE84B5-0718-4F7B-8F01-6146F20B99E6}"/>
               </a:ext>
             </a:extLst>
           </p:cNvPr>
@@ -6269,7 +6284,7 @@
           <p:cNvPr id="10" name="evidence-title-1">
             <a:extLst xmlns:a="http://schemas.openxmlformats.org/drawingml/2006/main">
               <a:ext uri="{FF2B5EF4-FFF2-40B4-BE49-F238E27FC236}">
-                <a16:creationId xmlns:a16="http://schemas.microsoft.com/office/drawing/2014/main" id="{3115C103-1A08-4407-84A0-17AC6E6305C2}"/>
+                <a16:creationId xmlns:a16="http://schemas.microsoft.com/office/drawing/2014/main" id="{1A198F1D-4D08-4FBC-9BFA-68E4A9041D64}"/>
               </a:ext>
             </a:extLst>
           </p:cNvPr>
@@ -6331,7 +6346,7 @@
           <p:cNvPr id="11" name="evidence-body-1">
             <a:extLst xmlns:a="http://schemas.openxmlformats.org/drawingml/2006/main">
               <a:ext uri="{FF2B5EF4-FFF2-40B4-BE49-F238E27FC236}">
-                <a16:creationId xmlns:a16="http://schemas.microsoft.com/office/drawing/2014/main" id="{A5D6C100-B2D6-4FFF-883F-A922BDBE88B7}"/>
+                <a16:creationId xmlns:a16="http://schemas.microsoft.com/office/drawing/2014/main" id="{451C640A-BE13-449A-BB9F-D211466BB483}"/>
               </a:ext>
             </a:extLst>
           </p:cNvPr>
@@ -6393,7 +6408,7 @@
           <p:cNvPr id="12" name="evidence-row-rule-1">
             <a:extLst xmlns:a="http://schemas.openxmlformats.org/drawingml/2006/main">
               <a:ext uri="{FF2B5EF4-FFF2-40B4-BE49-F238E27FC236}">
-                <a16:creationId xmlns:a16="http://schemas.microsoft.com/office/drawing/2014/main" id="{F199B2FD-1506-40FD-82B9-0B757FC64540}"/>
+                <a16:creationId xmlns:a16="http://schemas.microsoft.com/office/drawing/2014/main" id="{CAF5099C-A8E7-4B33-8722-DA6C6341EDD2}"/>
               </a:ext>
             </a:extLst>
           </p:cNvPr>
@@ -6424,7 +6439,7 @@
           <p:cNvPr id="13" name="evidence-num-2">
             <a:extLst xmlns:a="http://schemas.openxmlformats.org/drawingml/2006/main">
               <a:ext uri="{FF2B5EF4-FFF2-40B4-BE49-F238E27FC236}">
-                <a16:creationId xmlns:a16="http://schemas.microsoft.com/office/drawing/2014/main" id="{D943722A-B0C9-4551-97F0-B5DF8F3E28C6}"/>
+                <a16:creationId xmlns:a16="http://schemas.microsoft.com/office/drawing/2014/main" id="{A43FD8E6-F2A6-411F-845D-6B828CE7BB28}"/>
               </a:ext>
             </a:extLst>
           </p:cNvPr>
@@ -6486,7 +6501,7 @@
           <p:cNvPr id="14" name="evidence-title-2">
             <a:extLst xmlns:a="http://schemas.openxmlformats.org/drawingml/2006/main">
               <a:ext uri="{FF2B5EF4-FFF2-40B4-BE49-F238E27FC236}">
-                <a16:creationId xmlns:a16="http://schemas.microsoft.com/office/drawing/2014/main" id="{3C669CA6-84F8-4752-B281-F6F3A1533DA3}"/>
+                <a16:creationId xmlns:a16="http://schemas.microsoft.com/office/drawing/2014/main" id="{957A43DC-D7F5-4272-B1A6-810CF59A8FAB}"/>
               </a:ext>
             </a:extLst>
           </p:cNvPr>
@@ -6548,7 +6563,7 @@
           <p:cNvPr id="15" name="evidence-body-2">
             <a:extLst xmlns:a="http://schemas.openxmlformats.org/drawingml/2006/main">
               <a:ext uri="{FF2B5EF4-FFF2-40B4-BE49-F238E27FC236}">
-                <a16:creationId xmlns:a16="http://schemas.microsoft.com/office/drawing/2014/main" id="{C45A4CD0-6543-4C76-BE2B-10D9B9FBB1F0}"/>
+                <a16:creationId xmlns:a16="http://schemas.microsoft.com/office/drawing/2014/main" id="{F76762F5-F6F5-432B-8D63-6626E7CD2550}"/>
               </a:ext>
             </a:extLst>
           </p:cNvPr>
@@ -6610,7 +6625,7 @@
           <p:cNvPr id="16" name="evidence-row-rule-2">
             <a:extLst xmlns:a="http://schemas.openxmlformats.org/drawingml/2006/main">
               <a:ext uri="{FF2B5EF4-FFF2-40B4-BE49-F238E27FC236}">
-                <a16:creationId xmlns:a16="http://schemas.microsoft.com/office/drawing/2014/main" id="{A83B4CED-D343-4F84-91E3-8CF9D78570DF}"/>
+                <a16:creationId xmlns:a16="http://schemas.microsoft.com/office/drawing/2014/main" id="{552CD271-5F48-4DB6-BC08-66797FA27FEE}"/>
               </a:ext>
             </a:extLst>
           </p:cNvPr>
@@ -6641,7 +6656,7 @@
           <p:cNvPr id="17" name="evidence-num-3">
             <a:extLst xmlns:a="http://schemas.openxmlformats.org/drawingml/2006/main">
               <a:ext uri="{FF2B5EF4-FFF2-40B4-BE49-F238E27FC236}">
-                <a16:creationId xmlns:a16="http://schemas.microsoft.com/office/drawing/2014/main" id="{7D9F971C-DF1E-4E4C-8680-AF0F70FC5DB4}"/>
+                <a16:creationId xmlns:a16="http://schemas.microsoft.com/office/drawing/2014/main" id="{0CF6E665-285C-4D17-9D09-E945A0329364}"/>
               </a:ext>
             </a:extLst>
           </p:cNvPr>
@@ -6703,7 +6718,7 @@
           <p:cNvPr id="18" name="evidence-title-3">
             <a:extLst xmlns:a="http://schemas.openxmlformats.org/drawingml/2006/main">
               <a:ext uri="{FF2B5EF4-FFF2-40B4-BE49-F238E27FC236}">
-                <a16:creationId xmlns:a16="http://schemas.microsoft.com/office/drawing/2014/main" id="{8255B8E9-9355-4198-8F06-14ECC120FDCA}"/>
+                <a16:creationId xmlns:a16="http://schemas.microsoft.com/office/drawing/2014/main" id="{73657AA8-D47E-454F-B93D-E8D450BB151A}"/>
               </a:ext>
             </a:extLst>
           </p:cNvPr>
@@ -6765,7 +6780,7 @@
           <p:cNvPr id="19" name="evidence-body-3">
             <a:extLst xmlns:a="http://schemas.openxmlformats.org/drawingml/2006/main">
               <a:ext uri="{FF2B5EF4-FFF2-40B4-BE49-F238E27FC236}">
-                <a16:creationId xmlns:a16="http://schemas.microsoft.com/office/drawing/2014/main" id="{D0B47428-E509-42AC-A5CA-568B365AE356}"/>
+                <a16:creationId xmlns:a16="http://schemas.microsoft.com/office/drawing/2014/main" id="{DCAC02B6-D9CF-4CD9-80C0-FFED476013C7}"/>
               </a:ext>
             </a:extLst>
           </p:cNvPr>
@@ -6817,7 +6832,7 @@
                 <a:ea typeface="Apple SD Gothic Neo"/>
                 <a:cs typeface="Apple SD Gothic Neo"/>
               </a:rPr>
-              <a:t>checkout · dashboard · SDK · webhooks · local Anvil · CI</a:t>
+              <a:t>checkout · dashboard · SDK · 4 green CI jobs · 44 Foundry total (5 invariant)</a:t>
             </a:r>
           </a:p>
         </p:txBody>
@@ -6827,7 +6842,7 @@
           <p:cNvPr id="20" name="hard-gate-panel">
             <a:extLst xmlns:a="http://schemas.openxmlformats.org/drawingml/2006/main">
               <a:ext uri="{FF2B5EF4-FFF2-40B4-BE49-F238E27FC236}">
-                <a16:creationId xmlns:a16="http://schemas.microsoft.com/office/drawing/2014/main" id="{543FC94B-BD9B-4D20-85FC-23E7880C909B}"/>
+                <a16:creationId xmlns:a16="http://schemas.microsoft.com/office/drawing/2014/main" id="{A85E62D6-FCC3-443E-84E9-741BCDBB0DB8}"/>
               </a:ext>
             </a:extLst>
           </p:cNvPr>
@@ -6858,7 +6873,7 @@
           <p:cNvPr id="21" name="hard-gate-kicker">
             <a:extLst xmlns:a="http://schemas.openxmlformats.org/drawingml/2006/main">
               <a:ext uri="{FF2B5EF4-FFF2-40B4-BE49-F238E27FC236}">
-                <a16:creationId xmlns:a16="http://schemas.microsoft.com/office/drawing/2014/main" id="{0CBAABEC-9F16-471A-B6E7-07264B5392F8}"/>
+                <a16:creationId xmlns:a16="http://schemas.microsoft.com/office/drawing/2014/main" id="{EAB5498A-7D35-436B-AA8E-B7ECA8107610}"/>
               </a:ext>
             </a:extLst>
           </p:cNvPr>
@@ -6920,7 +6935,7 @@
           <p:cNvPr id="22" name="hard-gate-title">
             <a:extLst xmlns:a="http://schemas.openxmlformats.org/drawingml/2006/main">
               <a:ext uri="{FF2B5EF4-FFF2-40B4-BE49-F238E27FC236}">
-                <a16:creationId xmlns:a16="http://schemas.microsoft.com/office/drawing/2014/main" id="{ED11B886-46B7-4566-B588-963AB009AC08}"/>
+                <a16:creationId xmlns:a16="http://schemas.microsoft.com/office/drawing/2014/main" id="{5BEE5E0C-AE0E-4018-B554-2BA6BB3C5398}"/>
               </a:ext>
             </a:extLst>
           </p:cNvPr>
@@ -7009,7 +7024,7 @@
           <p:cNvPr id="23" name="hard-gate-body">
             <a:extLst xmlns:a="http://schemas.openxmlformats.org/drawingml/2006/main">
               <a:ext uri="{FF2B5EF4-FFF2-40B4-BE49-F238E27FC236}">
-                <a16:creationId xmlns:a16="http://schemas.microsoft.com/office/drawing/2014/main" id="{5C30FD2D-DB4C-4767-960F-4FD56F26B79B}"/>
+                <a16:creationId xmlns:a16="http://schemas.microsoft.com/office/drawing/2014/main" id="{2A2E66D3-69DE-4991-AB1E-0D07E099A3C3}"/>
               </a:ext>
             </a:extLst>
           </p:cNvPr>
@@ -7125,7 +7140,7 @@
           <p:cNvPr id="24" name="hard-gate-disclaimer">
             <a:extLst xmlns:a="http://schemas.openxmlformats.org/drawingml/2006/main">
               <a:ext uri="{FF2B5EF4-FFF2-40B4-BE49-F238E27FC236}">
-                <a16:creationId xmlns:a16="http://schemas.microsoft.com/office/drawing/2014/main" id="{B2071D5C-91E9-4D70-9EFD-DCF2D238D73C}"/>
+                <a16:creationId xmlns:a16="http://schemas.microsoft.com/office/drawing/2014/main" id="{F7C19226-F18F-4321-AA6B-4C2329566E8E}"/>
               </a:ext>
             </a:extLst>
           </p:cNvPr>
@@ -7159,7 +7174,7 @@
                 <a:spcPct val="100000"/>
               </a:lnSpc>
               <a:buNone/>
-              <a:defRPr sz="1125" b="0">
+              <a:defRPr sz="1200" b="0">
                 <a:solidFill>
                   <a:srgbClr val="E4E8E5"/>
                 </a:solidFill>
@@ -7169,7 +7184,7 @@
               </a:defRPr>
             </a:pPr>
             <a:r>
-              <a:rPr sz="1125" b="0">
+              <a:rPr sz="1200" b="0">
                 <a:solidFill>
                   <a:srgbClr val="E4E8E5"/>
                 </a:solidFill>
@@ -7187,7 +7202,7 @@
           <p:cNvPr id="25" name="footer-label-5">
             <a:extLst xmlns:a="http://schemas.openxmlformats.org/drawingml/2006/main">
               <a:ext uri="{FF2B5EF4-FFF2-40B4-BE49-F238E27FC236}">
-                <a16:creationId xmlns:a16="http://schemas.microsoft.com/office/drawing/2014/main" id="{DA0356B8-C7DC-41AA-94A8-644566E979E7}"/>
+                <a16:creationId xmlns:a16="http://schemas.microsoft.com/office/drawing/2014/main" id="{DDDC28C8-DA1B-4E19-9B44-5B073120A6D3}"/>
               </a:ext>
             </a:extLst>
           </p:cNvPr>
@@ -7249,7 +7264,7 @@
           <p:cNvPr id="26" name="footer-page-5">
             <a:extLst xmlns:a="http://schemas.openxmlformats.org/drawingml/2006/main">
               <a:ext uri="{FF2B5EF4-FFF2-40B4-BE49-F238E27FC236}">
-                <a16:creationId xmlns:a16="http://schemas.microsoft.com/office/drawing/2014/main" id="{A8D055F5-634D-4156-A367-455186F4F01B}"/>
+                <a16:creationId xmlns:a16="http://schemas.microsoft.com/office/drawing/2014/main" id="{A90CD05A-3455-4032-A703-583F3D3C1005}"/>
               </a:ext>
             </a:extLst>
           </p:cNvPr>
@@ -7309,7 +7324,7 @@
     </p:spTree>
     <p:extLst>
       <p:ext uri="{BB962C8B-B14F-4D97-AF65-F5344CB8AC3E}">
-        <p14:creationId xmlns:p14="http://schemas.microsoft.com/office/powerpoint/2010/main" val="1492074910"/>
+        <p14:creationId xmlns:p14="http://schemas.microsoft.com/office/powerpoint/2010/main" val="318989473"/>
       </p:ext>
     </p:extLst>
   </p:cSld>
@@ -7340,7 +7355,7 @@
           <p:cNvPr id="20" name="slide-6-title">
             <a:extLst xmlns:a="http://schemas.openxmlformats.org/drawingml/2006/main">
               <a:ext uri="{FF2B5EF4-FFF2-40B4-BE49-F238E27FC236}">
-                <a16:creationId xmlns:a16="http://schemas.microsoft.com/office/drawing/2014/main" id="{7B908FA6-3C2C-494F-976B-112AF16083A2}"/>
+                <a16:creationId xmlns:a16="http://schemas.microsoft.com/office/drawing/2014/main" id="{6C818DB7-0470-499B-A109-260D58DCCE4E}"/>
               </a:ext>
             </a:extLst>
           </p:cNvPr>
@@ -7392,7 +7407,7 @@
                 <a:ea typeface="Apple SD Gothic Neo"/>
                 <a:cs typeface="Apple SD Gothic Neo"/>
               </a:rPr>
-              <a:t>시장성은 큰 TAM이 아니라 8주 관찰값으로 줄입니다</a:t>
+              <a:t>시장 가정은 범위로, 공개 확인 실적은 별도로 표시합니다</a:t>
             </a:r>
           </a:p>
         </p:txBody>
@@ -7402,7 +7417,7 @@
           <p:cNvPr id="2" name="slide-6-subtitle">
             <a:extLst xmlns:a="http://schemas.openxmlformats.org/drawingml/2006/main">
               <a:ext uri="{FF2B5EF4-FFF2-40B4-BE49-F238E27FC236}">
-                <a16:creationId xmlns:a16="http://schemas.microsoft.com/office/drawing/2014/main" id="{6020CC0B-4619-4845-B11B-92FAAD05E576}"/>
+                <a16:creationId xmlns:a16="http://schemas.microsoft.com/office/drawing/2014/main" id="{54BD1B19-EAFF-4B0E-8E6A-502FB2D7F794}"/>
               </a:ext>
             </a:extLst>
           </p:cNvPr>
@@ -7454,7 +7469,7 @@
                 <a:ea typeface="Apple SD Gothic Neo"/>
                 <a:cs typeface="Apple SD Gothic Neo"/>
               </a:rPr>
-              <a:t>참고 시장과 현재 증거, Phase 3 목표를 같은 숫자로 섞지 않습니다.</a:t>
+              <a:t>참고 시장, 가정 기반 처리액, 현재 증거를 같은 숫자로 섞지 않습니다.</a:t>
             </a:r>
           </a:p>
         </p:txBody>
@@ -7464,7 +7479,7 @@
           <p:cNvPr id="3" name="slide-6-title-rule">
             <a:extLst xmlns:a="http://schemas.openxmlformats.org/drawingml/2006/main">
               <a:ext uri="{FF2B5EF4-FFF2-40B4-BE49-F238E27FC236}">
-                <a16:creationId xmlns:a16="http://schemas.microsoft.com/office/drawing/2014/main" id="{D8E68399-9018-46B0-9174-3AB1C48568F6}"/>
+                <a16:creationId xmlns:a16="http://schemas.microsoft.com/office/drawing/2014/main" id="{89417F13-E652-40C7-AD28-193638BFC4F1}"/>
               </a:ext>
             </a:extLst>
           </p:cNvPr>
@@ -7495,7 +7510,7 @@
           <p:cNvPr id="4" name="market-reference">
             <a:extLst xmlns:a="http://schemas.openxmlformats.org/drawingml/2006/main">
               <a:ext uri="{FF2B5EF4-FFF2-40B4-BE49-F238E27FC236}">
-                <a16:creationId xmlns:a16="http://schemas.microsoft.com/office/drawing/2014/main" id="{6574B574-9876-443F-8EA5-8B4EAAFD6A2C}"/>
+                <a16:creationId xmlns:a16="http://schemas.microsoft.com/office/drawing/2014/main" id="{0B03D70E-B634-4F82-A955-C69F3B26E2A1}"/>
               </a:ext>
             </a:extLst>
           </p:cNvPr>
@@ -7584,7 +7599,7 @@
           <p:cNvPr id="5" name="market-panel-0">
             <a:extLst xmlns:a="http://schemas.openxmlformats.org/drawingml/2006/main">
               <a:ext uri="{FF2B5EF4-FFF2-40B4-BE49-F238E27FC236}">
-                <a16:creationId xmlns:a16="http://schemas.microsoft.com/office/drawing/2014/main" id="{3A0A5D05-A238-40D5-A160-6C07A7129291}"/>
+                <a16:creationId xmlns:a16="http://schemas.microsoft.com/office/drawing/2014/main" id="{AE7160A0-83FD-4D6D-9C1D-C119368D61A9}"/>
               </a:ext>
             </a:extLst>
           </p:cNvPr>
@@ -7615,7 +7630,7 @@
           <p:cNvPr id="6" name="market-stat-0">
             <a:extLst xmlns:a="http://schemas.openxmlformats.org/drawingml/2006/main">
               <a:ext uri="{FF2B5EF4-FFF2-40B4-BE49-F238E27FC236}">
-                <a16:creationId xmlns:a16="http://schemas.microsoft.com/office/drawing/2014/main" id="{9E106667-9C6A-46AB-8000-BAF71C429780}"/>
+                <a16:creationId xmlns:a16="http://schemas.microsoft.com/office/drawing/2014/main" id="{DB60CBD6-A3E9-467E-9609-5742B74F4395}"/>
               </a:ext>
             </a:extLst>
           </p:cNvPr>
@@ -7649,7 +7664,7 @@
                 <a:spcPct val="90000"/>
               </a:lnSpc>
               <a:buNone/>
-              <a:defRPr sz="5100" b="1">
+              <a:defRPr sz="3900" b="1">
                 <a:solidFill>
                   <a:srgbClr val="070A08"/>
                 </a:solidFill>
@@ -7659,7 +7674,7 @@
               </a:defRPr>
             </a:pPr>
             <a:r>
-              <a:rPr sz="5100" b="1">
+              <a:rPr sz="3900" b="1">
                 <a:solidFill>
                   <a:srgbClr val="070A08"/>
                 </a:solidFill>
@@ -7667,7 +7682,7 @@
                 <a:ea typeface="Helvetica Neue"/>
                 <a:cs typeface="Helvetica Neue"/>
               </a:rPr>
-              <a:t>15</a:t>
+              <a:t>0.981억</a:t>
             </a:r>
           </a:p>
         </p:txBody>
@@ -7677,7 +7692,7 @@
           <p:cNvPr id="7" name="market-title-0">
             <a:extLst xmlns:a="http://schemas.openxmlformats.org/drawingml/2006/main">
               <a:ext uri="{FF2B5EF4-FFF2-40B4-BE49-F238E27FC236}">
-                <a16:creationId xmlns:a16="http://schemas.microsoft.com/office/drawing/2014/main" id="{EE381BF5-E47E-4335-9963-2F925085FBD9}"/>
+                <a16:creationId xmlns:a16="http://schemas.microsoft.com/office/drawing/2014/main" id="{18F60893-3F8F-4CD5-9C17-A93E68D3DE39}"/>
               </a:ext>
             </a:extLst>
           </p:cNvPr>
@@ -7729,7 +7744,7 @@
                 <a:ea typeface="Apple SD Gothic Neo"/>
                 <a:cs typeface="Apple SD Gothic Neo"/>
               </a:rPr>
-              <a:t>판매자 문제 인터뷰</a:t>
+              <a:t>LOW · 연간 처리액</a:t>
             </a:r>
           </a:p>
         </p:txBody>
@@ -7739,7 +7754,7 @@
           <p:cNvPr id="8" name="market-body-0">
             <a:extLst xmlns:a="http://schemas.openxmlformats.org/drawingml/2006/main">
               <a:ext uri="{FF2B5EF4-FFF2-40B4-BE49-F238E27FC236}">
-                <a16:creationId xmlns:a16="http://schemas.microsoft.com/office/drawing/2014/main" id="{89FBED31-15FD-4BD8-B0F1-D07FAE572DC8}"/>
+                <a16:creationId xmlns:a16="http://schemas.microsoft.com/office/drawing/2014/main" id="{BB6AAE8A-1F18-4419-AB60-8C75C1317D22}"/>
               </a:ext>
             </a:extLst>
           </p:cNvPr>
@@ -7791,7 +7806,34 @@
                 <a:ea typeface="Apple SD Gothic Neo"/>
                 <a:cs typeface="Apple SD Gothic Neo"/>
               </a:rPr>
-              <a:t>적합 merchant 비중과 정산 pain 확인</a:t>
+              <a:t>0.5% 예시 수수료 49만원</a:t>
+            </a:r>
+          </a:p>
+          <a:p xmlns:a="http://schemas.openxmlformats.org/drawingml/2006/main">
+            <a:pPr algn="l">
+              <a:lnSpc>
+                <a:spcPct val="105000"/>
+              </a:lnSpc>
+              <a:buNone/>
+              <a:defRPr sz="1350" b="0">
+                <a:solidFill>
+                  <a:srgbClr val="5F6661"/>
+                </a:solidFill>
+                <a:latin typeface="Apple SD Gothic Neo"/>
+                <a:ea typeface="Apple SD Gothic Neo"/>
+                <a:cs typeface="Apple SD Gothic Neo"/>
+              </a:defRPr>
+            </a:pPr>
+            <a:r>
+              <a:rPr sz="1350" b="0">
+                <a:solidFill>
+                  <a:srgbClr val="5F6661"/>
+                </a:solidFill>
+                <a:latin typeface="Apple SD Gothic Neo"/>
+                <a:ea typeface="Apple SD Gothic Neo"/>
+                <a:cs typeface="Apple SD Gothic Neo"/>
+              </a:rPr>
+              <a:t>적격 0.1% × checkout 5%</a:t>
             </a:r>
           </a:p>
         </p:txBody>
@@ -7801,7 +7843,7 @@
           <p:cNvPr id="9" name="market-panel-1">
             <a:extLst xmlns:a="http://schemas.openxmlformats.org/drawingml/2006/main">
               <a:ext uri="{FF2B5EF4-FFF2-40B4-BE49-F238E27FC236}">
-                <a16:creationId xmlns:a16="http://schemas.microsoft.com/office/drawing/2014/main" id="{2CD821B2-BBB7-4CBC-8C84-41C11C24D5A8}"/>
+                <a16:creationId xmlns:a16="http://schemas.microsoft.com/office/drawing/2014/main" id="{EE97E484-75DB-4F31-9C8A-8D03065A8990}"/>
               </a:ext>
             </a:extLst>
           </p:cNvPr>
@@ -7832,7 +7874,7 @@
           <p:cNvPr id="10" name="market-stat-1">
             <a:extLst xmlns:a="http://schemas.openxmlformats.org/drawingml/2006/main">
               <a:ext uri="{FF2B5EF4-FFF2-40B4-BE49-F238E27FC236}">
-                <a16:creationId xmlns:a16="http://schemas.microsoft.com/office/drawing/2014/main" id="{8DAF28BE-7B69-4AC0-A94E-6430FA093C40}"/>
+                <a16:creationId xmlns:a16="http://schemas.microsoft.com/office/drawing/2014/main" id="{833B315C-E2CB-4154-9702-03854C5F274B}"/>
               </a:ext>
             </a:extLst>
           </p:cNvPr>
@@ -7866,7 +7908,7 @@
                 <a:spcPct val="90000"/>
               </a:lnSpc>
               <a:buNone/>
-              <a:defRPr sz="5100" b="1">
+              <a:defRPr sz="3900" b="1">
                 <a:solidFill>
                   <a:srgbClr val="113D29"/>
                 </a:solidFill>
@@ -7876,7 +7918,7 @@
               </a:defRPr>
             </a:pPr>
             <a:r>
-              <a:rPr sz="5100" b="1">
+              <a:rPr sz="3900" b="1">
                 <a:solidFill>
                   <a:srgbClr val="113D29"/>
                 </a:solidFill>
@@ -7884,7 +7926,7 @@
                 <a:ea typeface="Helvetica Neue"/>
                 <a:cs typeface="Helvetica Neue"/>
               </a:rPr>
-              <a:t>3</a:t>
+              <a:t>9.811억</a:t>
             </a:r>
           </a:p>
         </p:txBody>
@@ -7894,7 +7936,7 @@
           <p:cNvPr id="11" name="market-title-1">
             <a:extLst xmlns:a="http://schemas.openxmlformats.org/drawingml/2006/main">
               <a:ext uri="{FF2B5EF4-FFF2-40B4-BE49-F238E27FC236}">
-                <a16:creationId xmlns:a16="http://schemas.microsoft.com/office/drawing/2014/main" id="{42E7F32B-A49D-49A5-A49F-102024E723B1}"/>
+                <a16:creationId xmlns:a16="http://schemas.microsoft.com/office/drawing/2014/main" id="{D95AB2C7-B087-48B4-9E9D-B6A688D5B647}"/>
               </a:ext>
             </a:extLst>
           </p:cNvPr>
@@ -7946,7 +7988,7 @@
                 <a:ea typeface="Apple SD Gothic Neo"/>
                 <a:cs typeface="Apple SD Gothic Neo"/>
               </a:rPr>
-              <a:t>서면 파일럿 관심</a:t>
+              <a:t>BASE · 연간 처리액</a:t>
             </a:r>
           </a:p>
         </p:txBody>
@@ -7956,7 +7998,7 @@
           <p:cNvPr id="12" name="market-body-1">
             <a:extLst xmlns:a="http://schemas.openxmlformats.org/drawingml/2006/main">
               <a:ext uri="{FF2B5EF4-FFF2-40B4-BE49-F238E27FC236}">
-                <a16:creationId xmlns:a16="http://schemas.microsoft.com/office/drawing/2014/main" id="{E0F2DE50-56F7-4874-96AE-DE972DDAF262}"/>
+                <a16:creationId xmlns:a16="http://schemas.microsoft.com/office/drawing/2014/main" id="{75958911-E4C9-40C8-9BB7-4C8F9BD65859}"/>
               </a:ext>
             </a:extLst>
           </p:cNvPr>
@@ -8008,7 +8050,34 @@
                 <a:ea typeface="Apple SD Gothic Neo"/>
                 <a:cs typeface="Apple SD Gothic Neo"/>
               </a:rPr>
-              <a:t>실제 도입 의향을 문서로 검증</a:t>
+              <a:t>0.5% 예시 수수료 491만원</a:t>
+            </a:r>
+          </a:p>
+          <a:p xmlns:a="http://schemas.openxmlformats.org/drawingml/2006/main">
+            <a:pPr algn="l">
+              <a:lnSpc>
+                <a:spcPct val="105000"/>
+              </a:lnSpc>
+              <a:buNone/>
+              <a:defRPr sz="1350" b="0">
+                <a:solidFill>
+                  <a:srgbClr val="5F6661"/>
+                </a:solidFill>
+                <a:latin typeface="Apple SD Gothic Neo"/>
+                <a:ea typeface="Apple SD Gothic Neo"/>
+                <a:cs typeface="Apple SD Gothic Neo"/>
+              </a:defRPr>
+            </a:pPr>
+            <a:r>
+              <a:rPr sz="1350" b="0">
+                <a:solidFill>
+                  <a:srgbClr val="5F6661"/>
+                </a:solidFill>
+                <a:latin typeface="Apple SD Gothic Neo"/>
+                <a:ea typeface="Apple SD Gothic Neo"/>
+                <a:cs typeface="Apple SD Gothic Neo"/>
+              </a:rPr>
+              <a:t>적격 0.5% × checkout 10%</a:t>
             </a:r>
           </a:p>
         </p:txBody>
@@ -8018,7 +8087,7 @@
           <p:cNvPr id="13" name="market-panel-2">
             <a:extLst xmlns:a="http://schemas.openxmlformats.org/drawingml/2006/main">
               <a:ext uri="{FF2B5EF4-FFF2-40B4-BE49-F238E27FC236}">
-                <a16:creationId xmlns:a16="http://schemas.microsoft.com/office/drawing/2014/main" id="{DDBB0F29-9257-4E0F-A96F-5957D029F508}"/>
+                <a16:creationId xmlns:a16="http://schemas.microsoft.com/office/drawing/2014/main" id="{0A29C6BD-7908-4842-A047-E965ABA94AEF}"/>
               </a:ext>
             </a:extLst>
           </p:cNvPr>
@@ -8049,7 +8118,7 @@
           <p:cNvPr id="14" name="market-stat-2">
             <a:extLst xmlns:a="http://schemas.openxmlformats.org/drawingml/2006/main">
               <a:ext uri="{FF2B5EF4-FFF2-40B4-BE49-F238E27FC236}">
-                <a16:creationId xmlns:a16="http://schemas.microsoft.com/office/drawing/2014/main" id="{94A408CA-AFAC-4583-A835-CEFC577C4A13}"/>
+                <a16:creationId xmlns:a16="http://schemas.microsoft.com/office/drawing/2014/main" id="{36258E96-EA35-477A-B57D-C1A6414F2FF4}"/>
               </a:ext>
             </a:extLst>
           </p:cNvPr>
@@ -8083,7 +8152,7 @@
                 <a:spcPct val="90000"/>
               </a:lnSpc>
               <a:buNone/>
-              <a:defRPr sz="5100" b="1">
+              <a:defRPr sz="3900" b="1">
                 <a:solidFill>
                   <a:srgbClr val="070A08"/>
                 </a:solidFill>
@@ -8093,7 +8162,7 @@
               </a:defRPr>
             </a:pPr>
             <a:r>
-              <a:rPr sz="5100" b="1">
+              <a:rPr sz="3900" b="1">
                 <a:solidFill>
                   <a:srgbClr val="070A08"/>
                 </a:solidFill>
@@ -8101,7 +8170,7 @@
                 <a:ea typeface="Helvetica Neue"/>
                 <a:cs typeface="Helvetica Neue"/>
               </a:rPr>
-              <a:t>2</a:t>
+              <a:t>39.24억</a:t>
             </a:r>
           </a:p>
         </p:txBody>
@@ -8111,7 +8180,7 @@
           <p:cNvPr id="15" name="market-title-2">
             <a:extLst xmlns:a="http://schemas.openxmlformats.org/drawingml/2006/main">
               <a:ext uri="{FF2B5EF4-FFF2-40B4-BE49-F238E27FC236}">
-                <a16:creationId xmlns:a16="http://schemas.microsoft.com/office/drawing/2014/main" id="{2DB025E3-D4B1-47BE-A019-9C36975FC211}"/>
+                <a16:creationId xmlns:a16="http://schemas.microsoft.com/office/drawing/2014/main" id="{93F3297C-425D-47FD-A72D-80C57E20363C}"/>
               </a:ext>
             </a:extLst>
           </p:cNvPr>
@@ -8163,7 +8232,7 @@
                 <a:ea typeface="Apple SD Gothic Neo"/>
                 <a:cs typeface="Apple SD Gothic Neo"/>
               </a:rPr>
-              <a:t>테스트넷 통합</a:t>
+              <a:t>HIGH · 연간 처리액</a:t>
             </a:r>
           </a:p>
         </p:txBody>
@@ -8173,7 +8242,7 @@
           <p:cNvPr id="16" name="market-body-2">
             <a:extLst xmlns:a="http://schemas.openxmlformats.org/drawingml/2006/main">
               <a:ext uri="{FF2B5EF4-FFF2-40B4-BE49-F238E27FC236}">
-                <a16:creationId xmlns:a16="http://schemas.microsoft.com/office/drawing/2014/main" id="{7E35B9E2-361A-48C5-8408-4B0150BAB6A1}"/>
+                <a16:creationId xmlns:a16="http://schemas.microsoft.com/office/drawing/2014/main" id="{B6309FFE-0575-4E61-8DC3-8959A2943975}"/>
               </a:ext>
             </a:extLst>
           </p:cNvPr>
@@ -8225,7 +8294,34 @@
                 <a:ea typeface="Apple SD Gothic Neo"/>
                 <a:cs typeface="Apple SD Gothic Neo"/>
               </a:rPr>
-              <a:t>직접토큰 경로로 운영 가능성 측정</a:t>
+              <a:t>0.5% 예시 수수료 1,962만원</a:t>
+            </a:r>
+          </a:p>
+          <a:p xmlns:a="http://schemas.openxmlformats.org/drawingml/2006/main">
+            <a:pPr algn="l">
+              <a:lnSpc>
+                <a:spcPct val="105000"/>
+              </a:lnSpc>
+              <a:buNone/>
+              <a:defRPr sz="1350" b="0">
+                <a:solidFill>
+                  <a:srgbClr val="5F6661"/>
+                </a:solidFill>
+                <a:latin typeface="Apple SD Gothic Neo"/>
+                <a:ea typeface="Apple SD Gothic Neo"/>
+                <a:cs typeface="Apple SD Gothic Neo"/>
+              </a:defRPr>
+            </a:pPr>
+            <a:r>
+              <a:rPr sz="1350" b="0">
+                <a:solidFill>
+                  <a:srgbClr val="5F6661"/>
+                </a:solidFill>
+                <a:latin typeface="Apple SD Gothic Neo"/>
+                <a:ea typeface="Apple SD Gothic Neo"/>
+                <a:cs typeface="Apple SD Gothic Neo"/>
+              </a:rPr>
+              <a:t>적격 1.0% × checkout 20%</a:t>
             </a:r>
           </a:p>
         </p:txBody>
@@ -8235,7 +8331,7 @@
           <p:cNvPr id="17" name="market-zero">
             <a:extLst xmlns:a="http://schemas.openxmlformats.org/drawingml/2006/main">
               <a:ext uri="{FF2B5EF4-FFF2-40B4-BE49-F238E27FC236}">
-                <a16:creationId xmlns:a16="http://schemas.microsoft.com/office/drawing/2014/main" id="{89AD7E13-8387-4C5F-9AC7-BDB93BF0C29D}"/>
+                <a16:creationId xmlns:a16="http://schemas.microsoft.com/office/drawing/2014/main" id="{47E3B717-B945-4E61-8B08-345ADAFED3EF}"/>
               </a:ext>
             </a:extLst>
           </p:cNvPr>
@@ -8287,7 +8383,7 @@
                 <a:ea typeface="Apple SD Gothic Neo"/>
                 <a:cs typeface="Apple SD Gothic Neo"/>
               </a:rPr>
-              <a:t>현재 실적: 인터뷰 0 · 서면 관심 0 · merchant 통합 0  /  위 숫자는 Phase 3 목표입니다.</a:t>
+              <a:t>공개 확인 실적: 인터뷰 0 · 서면 관심 0 · merchant 통합 0  /  비공개·오프라인 활동은 신청자 확인 필요</a:t>
             </a:r>
           </a:p>
         </p:txBody>
@@ -8297,7 +8393,7 @@
           <p:cNvPr id="18" name="footer-label-6">
             <a:extLst xmlns:a="http://schemas.openxmlformats.org/drawingml/2006/main">
               <a:ext uri="{FF2B5EF4-FFF2-40B4-BE49-F238E27FC236}">
-                <a16:creationId xmlns:a16="http://schemas.microsoft.com/office/drawing/2014/main" id="{E3F6E0A3-9533-4709-ABE6-4E2729B0080E}"/>
+                <a16:creationId xmlns:a16="http://schemas.microsoft.com/office/drawing/2014/main" id="{9F6CCE0B-42A8-4B9C-9847-4FF4DAB42709}"/>
               </a:ext>
             </a:extLst>
           </p:cNvPr>
@@ -8359,7 +8455,7 @@
           <p:cNvPr id="19" name="footer-page-6">
             <a:extLst xmlns:a="http://schemas.openxmlformats.org/drawingml/2006/main">
               <a:ext uri="{FF2B5EF4-FFF2-40B4-BE49-F238E27FC236}">
-                <a16:creationId xmlns:a16="http://schemas.microsoft.com/office/drawing/2014/main" id="{CB453B10-5F6B-47DD-9FFF-719787F3FF85}"/>
+                <a16:creationId xmlns:a16="http://schemas.microsoft.com/office/drawing/2014/main" id="{8A72F9A9-42F1-40C8-BAA4-8D0198F9D5C4}"/>
               </a:ext>
             </a:extLst>
           </p:cNvPr>
@@ -8419,7 +8515,7 @@
     </p:spTree>
     <p:extLst>
       <p:ext uri="{BB962C8B-B14F-4D97-AF65-F5344CB8AC3E}">
-        <p14:creationId xmlns:p14="http://schemas.microsoft.com/office/powerpoint/2010/main" val="2030895967"/>
+        <p14:creationId xmlns:p14="http://schemas.microsoft.com/office/powerpoint/2010/main" val="237990688"/>
       </p:ext>
     </p:extLst>
   </p:cSld>
@@ -8450,7 +8546,7 @@
           <p:cNvPr id="23" name="slide-7-title">
             <a:extLst xmlns:a="http://schemas.openxmlformats.org/drawingml/2006/main">
               <a:ext uri="{FF2B5EF4-FFF2-40B4-BE49-F238E27FC236}">
-                <a16:creationId xmlns:a16="http://schemas.microsoft.com/office/drawing/2014/main" id="{959C63FF-6B6D-4287-90BA-BF3B5C3F029D}"/>
+                <a16:creationId xmlns:a16="http://schemas.microsoft.com/office/drawing/2014/main" id="{E7E21E0F-0FA8-4107-BB4D-D52D8ACAB684}"/>
               </a:ext>
             </a:extLst>
           </p:cNvPr>
@@ -8512,7 +8608,7 @@
           <p:cNvPr id="2" name="slide-7-subtitle">
             <a:extLst xmlns:a="http://schemas.openxmlformats.org/drawingml/2006/main">
               <a:ext uri="{FF2B5EF4-FFF2-40B4-BE49-F238E27FC236}">
-                <a16:creationId xmlns:a16="http://schemas.microsoft.com/office/drawing/2014/main" id="{E7AED1F6-F95B-4E60-969A-99274FC4923B}"/>
+                <a16:creationId xmlns:a16="http://schemas.microsoft.com/office/drawing/2014/main" id="{D3EC8ADD-2A71-4B56-A0A3-48941DC6B788}"/>
               </a:ext>
             </a:extLst>
           </p:cNvPr>
@@ -8574,7 +8670,7 @@
           <p:cNvPr id="3" name="slide-7-title-rule">
             <a:extLst xmlns:a="http://schemas.openxmlformats.org/drawingml/2006/main">
               <a:ext uri="{FF2B5EF4-FFF2-40B4-BE49-F238E27FC236}">
-                <a16:creationId xmlns:a16="http://schemas.microsoft.com/office/drawing/2014/main" id="{607EB87E-8C1A-40D7-9E51-C61C1AA83676}"/>
+                <a16:creationId xmlns:a16="http://schemas.microsoft.com/office/drawing/2014/main" id="{2228140F-1B08-4ED2-A8ED-62CBC1087AC7}"/>
               </a:ext>
             </a:extLst>
           </p:cNvPr>
@@ -8605,7 +8701,7 @@
           <p:cNvPr id="4" name="roadmap-line">
             <a:extLst xmlns:a="http://schemas.openxmlformats.org/drawingml/2006/main">
               <a:ext uri="{FF2B5EF4-FFF2-40B4-BE49-F238E27FC236}">
-                <a16:creationId xmlns:a16="http://schemas.microsoft.com/office/drawing/2014/main" id="{B616B896-FEBE-4811-B7C3-8B625AD686B7}"/>
+                <a16:creationId xmlns:a16="http://schemas.microsoft.com/office/drawing/2014/main" id="{24C2BF5F-447A-4DB3-8E04-C3AD3C9E45CA}"/>
               </a:ext>
             </a:extLst>
           </p:cNvPr>
@@ -8636,7 +8732,7 @@
           <p:cNvPr id="5" name="roadmap-node-0">
             <a:extLst xmlns:a="http://schemas.openxmlformats.org/drawingml/2006/main">
               <a:ext uri="{FF2B5EF4-FFF2-40B4-BE49-F238E27FC236}">
-                <a16:creationId xmlns:a16="http://schemas.microsoft.com/office/drawing/2014/main" id="{61A6BF2A-1240-4464-984A-B69A597A8ECD}"/>
+                <a16:creationId xmlns:a16="http://schemas.microsoft.com/office/drawing/2014/main" id="{22F6773F-1242-41F9-8296-D228E43E585E}"/>
               </a:ext>
             </a:extLst>
           </p:cNvPr>
@@ -8667,7 +8763,7 @@
           <p:cNvPr id="6" name="roadmap-node-1">
             <a:extLst xmlns:a="http://schemas.openxmlformats.org/drawingml/2006/main">
               <a:ext uri="{FF2B5EF4-FFF2-40B4-BE49-F238E27FC236}">
-                <a16:creationId xmlns:a16="http://schemas.microsoft.com/office/drawing/2014/main" id="{D64A660D-5755-48F0-8A84-1E806298E650}"/>
+                <a16:creationId xmlns:a16="http://schemas.microsoft.com/office/drawing/2014/main" id="{C28C5A1E-4D5D-4FEC-8D7B-A8A732C1DC7F}"/>
               </a:ext>
             </a:extLst>
           </p:cNvPr>
@@ -8698,7 +8794,7 @@
           <p:cNvPr id="7" name="roadmap-node-2">
             <a:extLst xmlns:a="http://schemas.openxmlformats.org/drawingml/2006/main">
               <a:ext uri="{FF2B5EF4-FFF2-40B4-BE49-F238E27FC236}">
-                <a16:creationId xmlns:a16="http://schemas.microsoft.com/office/drawing/2014/main" id="{B7425A6D-7A0B-4C82-9F4F-4B7260E8F43C}"/>
+                <a16:creationId xmlns:a16="http://schemas.microsoft.com/office/drawing/2014/main" id="{67A0D888-DA14-46B2-9EA0-3E5B40779255}"/>
               </a:ext>
             </a:extLst>
           </p:cNvPr>
@@ -8729,7 +8825,7 @@
           <p:cNvPr id="8" name="roadmap-label-0">
             <a:extLst xmlns:a="http://schemas.openxmlformats.org/drawingml/2006/main">
               <a:ext uri="{FF2B5EF4-FFF2-40B4-BE49-F238E27FC236}">
-                <a16:creationId xmlns:a16="http://schemas.microsoft.com/office/drawing/2014/main" id="{DCC7C644-05D9-499F-83FB-11C9AE5BD924}"/>
+                <a16:creationId xmlns:a16="http://schemas.microsoft.com/office/drawing/2014/main" id="{F0B686B4-8A00-4A10-AAF2-C401486AACB3}"/>
               </a:ext>
             </a:extLst>
           </p:cNvPr>
@@ -8791,7 +8887,7 @@
           <p:cNvPr id="9" name="roadmap-title-0">
             <a:extLst xmlns:a="http://schemas.openxmlformats.org/drawingml/2006/main">
               <a:ext uri="{FF2B5EF4-FFF2-40B4-BE49-F238E27FC236}">
-                <a16:creationId xmlns:a16="http://schemas.microsoft.com/office/drawing/2014/main" id="{97BAF230-D1F7-40B7-8E68-ECD9D84EBAEE}"/>
+                <a16:creationId xmlns:a16="http://schemas.microsoft.com/office/drawing/2014/main" id="{456A80C0-44E2-4941-9117-7BADE57F19E7}"/>
               </a:ext>
             </a:extLst>
           </p:cNvPr>
@@ -8853,7 +8949,7 @@
           <p:cNvPr id="10" name="roadmap-body-0">
             <a:extLst xmlns:a="http://schemas.openxmlformats.org/drawingml/2006/main">
               <a:ext uri="{FF2B5EF4-FFF2-40B4-BE49-F238E27FC236}">
-                <a16:creationId xmlns:a16="http://schemas.microsoft.com/office/drawing/2014/main" id="{CE215668-CD89-4129-A6D4-6A21E8AA8C53}"/>
+                <a16:creationId xmlns:a16="http://schemas.microsoft.com/office/drawing/2014/main" id="{6D583004-F3EC-45CD-862B-222635318EE9}"/>
               </a:ext>
             </a:extLst>
           </p:cNvPr>
@@ -8969,7 +9065,7 @@
           <p:cNvPr id="11" name="roadmap-label-1">
             <a:extLst xmlns:a="http://schemas.openxmlformats.org/drawingml/2006/main">
               <a:ext uri="{FF2B5EF4-FFF2-40B4-BE49-F238E27FC236}">
-                <a16:creationId xmlns:a16="http://schemas.microsoft.com/office/drawing/2014/main" id="{B8C2D55F-BBFC-4350-9F12-B925EA70E822}"/>
+                <a16:creationId xmlns:a16="http://schemas.microsoft.com/office/drawing/2014/main" id="{5C2F977A-679D-4BC7-9529-5CFEF2BE2751}"/>
               </a:ext>
             </a:extLst>
           </p:cNvPr>
@@ -9031,7 +9127,7 @@
           <p:cNvPr id="12" name="roadmap-title-1">
             <a:extLst xmlns:a="http://schemas.openxmlformats.org/drawingml/2006/main">
               <a:ext uri="{FF2B5EF4-FFF2-40B4-BE49-F238E27FC236}">
-                <a16:creationId xmlns:a16="http://schemas.microsoft.com/office/drawing/2014/main" id="{4FBE1871-C9A0-4528-A99D-AE99F2EE92A0}"/>
+                <a16:creationId xmlns:a16="http://schemas.microsoft.com/office/drawing/2014/main" id="{1AB88D8F-9F13-4ABA-9030-D3C0DDF827E2}"/>
               </a:ext>
             </a:extLst>
           </p:cNvPr>
@@ -9093,7 +9189,7 @@
           <p:cNvPr id="13" name="roadmap-body-1">
             <a:extLst xmlns:a="http://schemas.openxmlformats.org/drawingml/2006/main">
               <a:ext uri="{FF2B5EF4-FFF2-40B4-BE49-F238E27FC236}">
-                <a16:creationId xmlns:a16="http://schemas.microsoft.com/office/drawing/2014/main" id="{23374A93-5905-4666-A6C1-F890FCBBD59C}"/>
+                <a16:creationId xmlns:a16="http://schemas.microsoft.com/office/drawing/2014/main" id="{7527C268-3950-48A8-941B-CEC4B9891EC4}"/>
               </a:ext>
             </a:extLst>
           </p:cNvPr>
@@ -9209,7 +9305,7 @@
           <p:cNvPr id="14" name="roadmap-label-2">
             <a:extLst xmlns:a="http://schemas.openxmlformats.org/drawingml/2006/main">
               <a:ext uri="{FF2B5EF4-FFF2-40B4-BE49-F238E27FC236}">
-                <a16:creationId xmlns:a16="http://schemas.microsoft.com/office/drawing/2014/main" id="{1D9ADEC1-458D-4049-899C-2CE31D3CB979}"/>
+                <a16:creationId xmlns:a16="http://schemas.microsoft.com/office/drawing/2014/main" id="{E8E2C659-F9D3-4FC3-A5D7-E81AB2574D13}"/>
               </a:ext>
             </a:extLst>
           </p:cNvPr>
@@ -9271,7 +9367,7 @@
           <p:cNvPr id="15" name="roadmap-title-2">
             <a:extLst xmlns:a="http://schemas.openxmlformats.org/drawingml/2006/main">
               <a:ext uri="{FF2B5EF4-FFF2-40B4-BE49-F238E27FC236}">
-                <a16:creationId xmlns:a16="http://schemas.microsoft.com/office/drawing/2014/main" id="{6B9B6CF0-157B-4337-AF69-1ECB04C265DE}"/>
+                <a16:creationId xmlns:a16="http://schemas.microsoft.com/office/drawing/2014/main" id="{F72C9DF9-B755-4E5D-B8CB-C2C418E3C3BE}"/>
               </a:ext>
             </a:extLst>
           </p:cNvPr>
@@ -9333,7 +9429,7 @@
           <p:cNvPr id="16" name="roadmap-body-2">
             <a:extLst xmlns:a="http://schemas.openxmlformats.org/drawingml/2006/main">
               <a:ext uri="{FF2B5EF4-FFF2-40B4-BE49-F238E27FC236}">
-                <a16:creationId xmlns:a16="http://schemas.microsoft.com/office/drawing/2014/main" id="{BF26B77B-EF14-46B5-9D7F-2E3BDC7E7E46}"/>
+                <a16:creationId xmlns:a16="http://schemas.microsoft.com/office/drawing/2014/main" id="{6125CAAD-442C-40FB-ADDD-426D53E8554C}"/>
               </a:ext>
             </a:extLst>
           </p:cNvPr>
@@ -9449,7 +9545,7 @@
           <p:cNvPr id="17" name="roadmap-kpi-bg">
             <a:extLst xmlns:a="http://schemas.openxmlformats.org/drawingml/2006/main">
               <a:ext uri="{FF2B5EF4-FFF2-40B4-BE49-F238E27FC236}">
-                <a16:creationId xmlns:a16="http://schemas.microsoft.com/office/drawing/2014/main" id="{82917EF7-9285-49E1-AD11-C19F294BE165}"/>
+                <a16:creationId xmlns:a16="http://schemas.microsoft.com/office/drawing/2014/main" id="{87B7F115-BAA4-4D79-993F-CAF00F510A51}"/>
               </a:ext>
             </a:extLst>
           </p:cNvPr>
@@ -9480,7 +9576,7 @@
           <p:cNvPr id="18" name="roadmap-kpi-label">
             <a:extLst xmlns:a="http://schemas.openxmlformats.org/drawingml/2006/main">
               <a:ext uri="{FF2B5EF4-FFF2-40B4-BE49-F238E27FC236}">
-                <a16:creationId xmlns:a16="http://schemas.microsoft.com/office/drawing/2014/main" id="{A329FFC6-AD2F-4595-82AE-F84917C043B9}"/>
+                <a16:creationId xmlns:a16="http://schemas.microsoft.com/office/drawing/2014/main" id="{FF2CD198-A816-4CCA-B8D1-08E189E9B010}"/>
               </a:ext>
             </a:extLst>
           </p:cNvPr>
@@ -9542,7 +9638,7 @@
           <p:cNvPr id="19" name="roadmap-kpi">
             <a:extLst xmlns:a="http://schemas.openxmlformats.org/drawingml/2006/main">
               <a:ext uri="{FF2B5EF4-FFF2-40B4-BE49-F238E27FC236}">
-                <a16:creationId xmlns:a16="http://schemas.microsoft.com/office/drawing/2014/main" id="{172AB16B-9607-4752-94E8-CC32FCFE346A}"/>
+                <a16:creationId xmlns:a16="http://schemas.microsoft.com/office/drawing/2014/main" id="{2E852D7F-642F-4A59-9957-D21AF5D02FBF}"/>
               </a:ext>
             </a:extLst>
           </p:cNvPr>
@@ -9604,7 +9700,7 @@
           <p:cNvPr id="20" name="roadmap-kpi-note">
             <a:extLst xmlns:a="http://schemas.openxmlformats.org/drawingml/2006/main">
               <a:ext uri="{FF2B5EF4-FFF2-40B4-BE49-F238E27FC236}">
-                <a16:creationId xmlns:a16="http://schemas.microsoft.com/office/drawing/2014/main" id="{38B74DEC-A8FA-4E40-B9C8-CDE8A2058EAA}"/>
+                <a16:creationId xmlns:a16="http://schemas.microsoft.com/office/drawing/2014/main" id="{0E323E08-23AE-493C-9BD1-53423ED75CAA}"/>
               </a:ext>
             </a:extLst>
           </p:cNvPr>
@@ -9638,17 +9734,17 @@
                 <a:spcPct val="100000"/>
               </a:lnSpc>
               <a:buNone/>
-              <a:defRPr sz="1050" b="0">
-                <a:solidFill>
-                  <a:srgbClr val="5F6661"/>
-                </a:solidFill>
-                <a:latin typeface="Apple SD Gothic Neo"/>
-                <a:ea typeface="Apple SD Gothic Neo"/>
-                <a:cs typeface="Apple SD Gothic Neo"/>
-              </a:defRPr>
-            </a:pPr>
-            <a:r>
-              <a:rPr sz="1050" b="0">
+              <a:defRPr sz="1200" b="0">
+                <a:solidFill>
+                  <a:srgbClr val="5F6661"/>
+                </a:solidFill>
+                <a:latin typeface="Apple SD Gothic Neo"/>
+                <a:ea typeface="Apple SD Gothic Neo"/>
+                <a:cs typeface="Apple SD Gothic Neo"/>
+              </a:defRPr>
+            </a:pPr>
+            <a:r>
+              <a:rPr sz="1200" b="0">
                 <a:solidFill>
                   <a:srgbClr val="5F6661"/>
                 </a:solidFill>
@@ -9666,7 +9762,7 @@
           <p:cNvPr id="21" name="footer-label-7">
             <a:extLst xmlns:a="http://schemas.openxmlformats.org/drawingml/2006/main">
               <a:ext uri="{FF2B5EF4-FFF2-40B4-BE49-F238E27FC236}">
-                <a16:creationId xmlns:a16="http://schemas.microsoft.com/office/drawing/2014/main" id="{A535E790-5FF3-437E-BF21-6CCCD19FF830}"/>
+                <a16:creationId xmlns:a16="http://schemas.microsoft.com/office/drawing/2014/main" id="{7D59038B-2985-4B8F-A939-7DD2EB77DAB7}"/>
               </a:ext>
             </a:extLst>
           </p:cNvPr>
@@ -9728,7 +9824,7 @@
           <p:cNvPr id="22" name="footer-page-7">
             <a:extLst xmlns:a="http://schemas.openxmlformats.org/drawingml/2006/main">
               <a:ext uri="{FF2B5EF4-FFF2-40B4-BE49-F238E27FC236}">
-                <a16:creationId xmlns:a16="http://schemas.microsoft.com/office/drawing/2014/main" id="{3BE960AC-11E3-496C-A9CF-EEADA19C7426}"/>
+                <a16:creationId xmlns:a16="http://schemas.microsoft.com/office/drawing/2014/main" id="{1A635CF3-3CA8-4891-89BF-05FAB661390C}"/>
               </a:ext>
             </a:extLst>
           </p:cNvPr>
@@ -9788,7 +9884,7 @@
     </p:spTree>
     <p:extLst>
       <p:ext uri="{BB962C8B-B14F-4D97-AF65-F5344CB8AC3E}">
-        <p14:creationId xmlns:p14="http://schemas.microsoft.com/office/powerpoint/2010/main" val="76066890"/>
+        <p14:creationId xmlns:p14="http://schemas.microsoft.com/office/powerpoint/2010/main" val="124948788"/>
       </p:ext>
     </p:extLst>
   </p:cSld>
@@ -9819,7 +9915,7 @@
           <p:cNvPr id="12" name="close-eyebrow">
             <a:extLst xmlns:a="http://schemas.openxmlformats.org/drawingml/2006/main">
               <a:ext uri="{FF2B5EF4-FFF2-40B4-BE49-F238E27FC236}">
-                <a16:creationId xmlns:a16="http://schemas.microsoft.com/office/drawing/2014/main" id="{AB3B0E3D-6023-4DD0-A4A1-142B982DDCB2}"/>
+                <a16:creationId xmlns:a16="http://schemas.microsoft.com/office/drawing/2014/main" id="{08BB38D3-955B-4F93-A9FF-6536CCE8C97B}"/>
               </a:ext>
             </a:extLst>
           </p:cNvPr>
@@ -9881,7 +9977,7 @@
           <p:cNvPr id="2" name="close-title">
             <a:extLst xmlns:a="http://schemas.openxmlformats.org/drawingml/2006/main">
               <a:ext uri="{FF2B5EF4-FFF2-40B4-BE49-F238E27FC236}">
-                <a16:creationId xmlns:a16="http://schemas.microsoft.com/office/drawing/2014/main" id="{2629D657-046D-49FB-8F65-5F39CE0D5881}"/>
+                <a16:creationId xmlns:a16="http://schemas.microsoft.com/office/drawing/2014/main" id="{2005C197-685F-44AC-B5F5-87A5421972B1}"/>
               </a:ext>
             </a:extLst>
           </p:cNvPr>
@@ -9997,7 +10093,7 @@
           <p:cNvPr id="3" name="close-rule">
             <a:extLst xmlns:a="http://schemas.openxmlformats.org/drawingml/2006/main">
               <a:ext uri="{FF2B5EF4-FFF2-40B4-BE49-F238E27FC236}">
-                <a16:creationId xmlns:a16="http://schemas.microsoft.com/office/drawing/2014/main" id="{0540937B-37AF-4A05-B4CF-885A3B4A787C}"/>
+                <a16:creationId xmlns:a16="http://schemas.microsoft.com/office/drawing/2014/main" id="{3741DF44-E6B8-432D-ABED-2B6E8946244E}"/>
               </a:ext>
             </a:extLst>
           </p:cNvPr>
@@ -10028,7 +10124,7 @@
           <p:cNvPr id="4" name="close-team-label">
             <a:extLst xmlns:a="http://schemas.openxmlformats.org/drawingml/2006/main">
               <a:ext uri="{FF2B5EF4-FFF2-40B4-BE49-F238E27FC236}">
-                <a16:creationId xmlns:a16="http://schemas.microsoft.com/office/drawing/2014/main" id="{2211B17E-D732-466E-A83D-5731EEC84CC4}"/>
+                <a16:creationId xmlns:a16="http://schemas.microsoft.com/office/drawing/2014/main" id="{6B0CE559-0FCF-4A92-AADE-55783CDA565F}"/>
               </a:ext>
             </a:extLst>
           </p:cNvPr>
@@ -10090,7 +10186,7 @@
           <p:cNvPr id="5" name="close-team">
             <a:extLst xmlns:a="http://schemas.openxmlformats.org/drawingml/2006/main">
               <a:ext uri="{FF2B5EF4-FFF2-40B4-BE49-F238E27FC236}">
-                <a16:creationId xmlns:a16="http://schemas.microsoft.com/office/drawing/2014/main" id="{F76C3A4C-BF4E-4959-9047-7C91D976828C}"/>
+                <a16:creationId xmlns:a16="http://schemas.microsoft.com/office/drawing/2014/main" id="{F1AE9F49-398E-4CC2-B602-79829E810C60}"/>
               </a:ext>
             </a:extLst>
           </p:cNvPr>
@@ -10102,7 +10198,7 @@
         <p:spPr>
           <a:xfrm xmlns:a="http://schemas.openxmlformats.org/drawingml/2006/main">
             <a:off x="1390650" y="4800600"/>
-            <a:ext cx="3905250" cy="266700"/>
+            <a:ext cx="4953000" cy="266700"/>
           </a:xfrm>
           <a:prstGeom xmlns:a="http://schemas.openxmlformats.org/drawingml/2006/main" prst="rect">
             <a:avLst/>
@@ -10142,7 +10238,7 @@
                 <a:ea typeface="Helvetica Neue"/>
                 <a:cs typeface="Helvetica Neue"/>
               </a:rPr>
-              <a:t>Founder-led · product &amp; engineering</a:t>
+              <a:t>Product &amp; engineering · public profile pending</a:t>
             </a:r>
           </a:p>
         </p:txBody>
@@ -10152,7 +10248,7 @@
           <p:cNvPr id="6" name="close-ask-label">
             <a:extLst xmlns:a="http://schemas.openxmlformats.org/drawingml/2006/main">
               <a:ext uri="{FF2B5EF4-FFF2-40B4-BE49-F238E27FC236}">
-                <a16:creationId xmlns:a16="http://schemas.microsoft.com/office/drawing/2014/main" id="{A6ED9400-0D59-4001-9BD2-B76FB1492BFF}"/>
+                <a16:creationId xmlns:a16="http://schemas.microsoft.com/office/drawing/2014/main" id="{4B95EFA0-9C6D-4FF0-8FB1-CA9E6FB65598}"/>
               </a:ext>
             </a:extLst>
           </p:cNvPr>
@@ -10214,7 +10310,7 @@
           <p:cNvPr id="7" name="close-ask">
             <a:extLst xmlns:a="http://schemas.openxmlformats.org/drawingml/2006/main">
               <a:ext uri="{FF2B5EF4-FFF2-40B4-BE49-F238E27FC236}">
-                <a16:creationId xmlns:a16="http://schemas.microsoft.com/office/drawing/2014/main" id="{F35B2931-C5DC-4285-AD7B-FD7ED831CE3C}"/>
+                <a16:creationId xmlns:a16="http://schemas.microsoft.com/office/drawing/2014/main" id="{4AEDAC2D-0C4F-4466-A6D0-8F8106C1B014}"/>
               </a:ext>
             </a:extLst>
           </p:cNvPr>
@@ -10276,7 +10372,7 @@
           <p:cNvPr id="8" name="close-status-bg">
             <a:extLst xmlns:a="http://schemas.openxmlformats.org/drawingml/2006/main">
               <a:ext uri="{FF2B5EF4-FFF2-40B4-BE49-F238E27FC236}">
-                <a16:creationId xmlns:a16="http://schemas.microsoft.com/office/drawing/2014/main" id="{8154AFFC-61DB-4EE4-BAF0-0B725098389A}"/>
+                <a16:creationId xmlns:a16="http://schemas.microsoft.com/office/drawing/2014/main" id="{F5DEC865-69C0-46F3-B673-79AF19253244}"/>
               </a:ext>
             </a:extLst>
           </p:cNvPr>
@@ -10307,7 +10403,7 @@
           <p:cNvPr id="9" name="close-status-label">
             <a:extLst xmlns:a="http://schemas.openxmlformats.org/drawingml/2006/main">
               <a:ext uri="{FF2B5EF4-FFF2-40B4-BE49-F238E27FC236}">
-                <a16:creationId xmlns:a16="http://schemas.microsoft.com/office/drawing/2014/main" id="{62F2CCD9-7446-4AD8-BA5A-E2C214C7278F}"/>
+                <a16:creationId xmlns:a16="http://schemas.microsoft.com/office/drawing/2014/main" id="{CEF2D567-EFB7-4DDB-8CC9-401C64016A49}"/>
               </a:ext>
             </a:extLst>
           </p:cNvPr>
@@ -10341,7 +10437,7 @@
                 <a:spcPct val="100000"/>
               </a:lnSpc>
               <a:buNone/>
-              <a:defRPr sz="975" b="1">
+              <a:defRPr sz="1200" b="1">
                 <a:solidFill>
                   <a:srgbClr val="7CF6B1"/>
                 </a:solidFill>
@@ -10351,7 +10447,7 @@
               </a:defRPr>
             </a:pPr>
             <a:r>
-              <a:rPr sz="975" b="1">
+              <a:rPr sz="1200" b="1">
                 <a:solidFill>
                   <a:srgbClr val="7CF6B1"/>
                 </a:solidFill>
@@ -10369,7 +10465,7 @@
           <p:cNvPr id="10" name="close-status-value">
             <a:extLst xmlns:a="http://schemas.openxmlformats.org/drawingml/2006/main">
               <a:ext uri="{FF2B5EF4-FFF2-40B4-BE49-F238E27FC236}">
-                <a16:creationId xmlns:a16="http://schemas.microsoft.com/office/drawing/2014/main" id="{F76FCE29-A1F0-4330-A504-F0AEE734807A}"/>
+                <a16:creationId xmlns:a16="http://schemas.microsoft.com/office/drawing/2014/main" id="{4D5BBC29-73CA-4896-B4C0-2C9283CA218C}"/>
               </a:ext>
             </a:extLst>
           </p:cNvPr>
@@ -10431,7 +10527,7 @@
           <p:cNvPr id="11" name="close-link">
             <a:extLst xmlns:a="http://schemas.openxmlformats.org/drawingml/2006/main">
               <a:ext uri="{FF2B5EF4-FFF2-40B4-BE49-F238E27FC236}">
-                <a16:creationId xmlns:a16="http://schemas.microsoft.com/office/drawing/2014/main" id="{911BD573-CDB5-4BCA-AA06-2F859A1C3277}"/>
+                <a16:creationId xmlns:a16="http://schemas.microsoft.com/office/drawing/2014/main" id="{B2E11C60-08E5-4079-B152-D82A6FC5DDBB}"/>
               </a:ext>
             </a:extLst>
           </p:cNvPr>
@@ -10465,7 +10561,7 @@
                 <a:spcPct val="100000"/>
               </a:lnSpc>
               <a:buNone/>
-              <a:defRPr sz="1125" b="0">
+              <a:defRPr sz="1200" b="0">
                 <a:solidFill>
                   <a:srgbClr val="5F6661"/>
                 </a:solidFill>
@@ -10475,7 +10571,7 @@
               </a:defRPr>
             </a:pPr>
             <a:r>
-              <a:rPr sz="1125" b="0">
+              <a:rPr sz="1200" b="0">
                 <a:solidFill>
                   <a:srgbClr val="5F6661"/>
                 </a:solidFill>
@@ -10491,7 +10587,7 @@
     </p:spTree>
     <p:extLst>
       <p:ext uri="{BB962C8B-B14F-4D97-AF65-F5344CB8AC3E}">
-        <p14:creationId xmlns:p14="http://schemas.microsoft.com/office/powerpoint/2010/main" val="14088954"/>
+        <p14:creationId xmlns:p14="http://schemas.microsoft.com/office/powerpoint/2010/main" val="153380096"/>
       </p:ext>
     </p:extLst>
   </p:cSld>

</xml_diff>